<commit_message>
feat(spanisch): Erweiterte PPTX-Präsentationen (9-15 Folien pro Lektion)
- Jede Lektion von 5-8 auf 9-15 Folien erweitert
- Neue Folientypen: Lernziele, Dialoge, Content-Folien
- Vokabeln auf mehrere Folien aufgeteilt
- Mehrere Übung/Lösung-Paare pro Lektion
- Grammatikfolien mit Tipps erweitert
- Generator-Script komplett überarbeitet

🤖 Generated with [Claude Code](https://claude.com/claude-code)

Co-Authored-By: Claude Opus 4.5 <noreply@anthropic.com>
</commit_message>
<xml_diff>
--- a/projects/spanisch/kl07/sequenz-01-empezamos/01d-quetal-test/PPT-01d.pptx
+++ b/projects/spanisch/kl07/sequenz-01-empezamos/01d-quetal-test/PPT-01d.pptx
@@ -9,6 +9,13 @@
     <p:sldId id="257" r:id="rId8"/>
     <p:sldId id="258" r:id="rId9"/>
     <p:sldId id="259" r:id="rId10"/>
+    <p:sldId id="260" r:id="rId11"/>
+    <p:sldId id="261" r:id="rId12"/>
+    <p:sldId id="262" r:id="rId13"/>
+    <p:sldId id="263" r:id="rId14"/>
+    <p:sldId id="264" r:id="rId15"/>
+    <p:sldId id="265" r:id="rId16"/>
+    <p:sldId id="266" r:id="rId17"/>
   </p:sldIdLst>
   <p:sldSz cx="12191695" cy="6858000" type="screen4x3"/>
   <p:notesSz cx="6858000" cy="9144000"/>
@@ -3201,7 +3208,7 @@
               </a:defRPr>
             </a:pPr>
             <a:r>
-              <a:t>Minitest Sequenz 1</a:t>
+              <a:t>Wiederholung Sequenz 1</a:t>
             </a:r>
           </a:p>
         </p:txBody>
@@ -3310,6 +3317,941 @@
             </a:pPr>
             <a:r>
               <a:t>🇪🇸</a:t>
+            </a:r>
+          </a:p>
+        </p:txBody>
+      </p:sp>
+    </p:spTree>
+  </p:cSld>
+  <p:clrMapOvr>
+    <a:masterClrMapping/>
+  </p:clrMapOvr>
+</p:sld>
+</file>
+
+<file path=ppt/slides/slide10.xml><?xml version="1.0" encoding="utf-8"?>
+<p:sld xmlns:a="http://schemas.openxmlformats.org/drawingml/2006/main" xmlns:p="http://schemas.openxmlformats.org/presentationml/2006/main" xmlns:r="http://schemas.openxmlformats.org/officeDocument/2006/relationships">
+  <p:cSld>
+    <p:spTree>
+      <p:nvGrpSpPr>
+        <p:cNvPr id="1" name=""/>
+        <p:cNvGrpSpPr/>
+        <p:nvPr/>
+      </p:nvGrpSpPr>
+      <p:grpSpPr/>
+      <p:sp>
+        <p:nvSpPr>
+          <p:cNvPr id="2" name="Rectangle 1"/>
+          <p:cNvSpPr/>
+          <p:nvPr/>
+        </p:nvSpPr>
+        <p:spPr>
+          <a:xfrm>
+            <a:off x="0" y="0"/>
+            <a:ext cx="12191695" cy="457200"/>
+          </a:xfrm>
+          <a:prstGeom prst="rect">
+            <a:avLst/>
+          </a:prstGeom>
+          <a:solidFill>
+            <a:srgbClr val="C41E3A"/>
+          </a:solidFill>
+          <a:ln>
+            <a:noFill/>
+          </a:ln>
+        </p:spPr>
+        <p:style>
+          <a:lnRef idx="1">
+            <a:schemeClr val="accent1"/>
+          </a:lnRef>
+          <a:fillRef idx="3">
+            <a:schemeClr val="accent1"/>
+          </a:fillRef>
+          <a:effectRef idx="2">
+            <a:schemeClr val="accent1"/>
+          </a:effectRef>
+          <a:fontRef idx="minor">
+            <a:schemeClr val="lt1"/>
+          </a:fontRef>
+        </p:style>
+        <p:txBody>
+          <a:bodyPr rtlCol="0" anchor="ctr"/>
+          <a:lstStyle/>
+          <a:p>
+            <a:pPr algn="ctr"/>
+          </a:p>
+        </p:txBody>
+      </p:sp>
+      <p:sp>
+        <p:nvSpPr>
+          <p:cNvPr id="3" name="TextBox 2"/>
+          <p:cNvSpPr txBox="1"/>
+          <p:nvPr/>
+        </p:nvSpPr>
+        <p:spPr>
+          <a:xfrm>
+            <a:off x="274320" y="91440"/>
+            <a:ext cx="3657600" cy="274320"/>
+          </a:xfrm>
+          <a:prstGeom prst="rect">
+            <a:avLst/>
+          </a:prstGeom>
+          <a:noFill/>
+        </p:spPr>
+        <p:txBody>
+          <a:bodyPr wrap="none">
+            <a:spAutoFit/>
+          </a:bodyPr>
+          <a:lstStyle/>
+          <a:p>
+            <a:pPr algn="l">
+              <a:defRPr sz="1400" b="1">
+                <a:solidFill>
+                  <a:srgbClr val="FFFFFF"/>
+                </a:solidFill>
+                <a:latin typeface="Arial"/>
+              </a:defRPr>
+            </a:pPr>
+            <a:r>
+              <a:t>Spanisch Klasse 7 · LP-01d</a:t>
+            </a:r>
+          </a:p>
+        </p:txBody>
+      </p:sp>
+      <p:sp>
+        <p:nvSpPr>
+          <p:cNvPr id="4" name="Rectangle 3"/>
+          <p:cNvSpPr/>
+          <p:nvPr/>
+        </p:nvSpPr>
+        <p:spPr>
+          <a:xfrm>
+            <a:off x="0" y="6583680"/>
+            <a:ext cx="12191695" cy="274320"/>
+          </a:xfrm>
+          <a:prstGeom prst="rect">
+            <a:avLst/>
+          </a:prstGeom>
+          <a:solidFill>
+            <a:srgbClr val="F5F5F5"/>
+          </a:solidFill>
+          <a:ln>
+            <a:noFill/>
+          </a:ln>
+        </p:spPr>
+        <p:style>
+          <a:lnRef idx="1">
+            <a:schemeClr val="accent1"/>
+          </a:lnRef>
+          <a:fillRef idx="3">
+            <a:schemeClr val="accent1"/>
+          </a:fillRef>
+          <a:effectRef idx="2">
+            <a:schemeClr val="accent1"/>
+          </a:effectRef>
+          <a:fontRef idx="minor">
+            <a:schemeClr val="lt1"/>
+          </a:fontRef>
+        </p:style>
+        <p:txBody>
+          <a:bodyPr rtlCol="0" anchor="ctr"/>
+          <a:lstStyle/>
+          <a:p>
+            <a:pPr algn="ctr"/>
+          </a:p>
+        </p:txBody>
+      </p:sp>
+      <p:sp>
+        <p:nvSpPr>
+          <p:cNvPr id="5" name="TextBox 4"/>
+          <p:cNvSpPr txBox="1"/>
+          <p:nvPr/>
+        </p:nvSpPr>
+        <p:spPr>
+          <a:xfrm>
+            <a:off x="274320" y="6601968"/>
+            <a:ext cx="4572000" cy="228600"/>
+          </a:xfrm>
+          <a:prstGeom prst="rect">
+            <a:avLst/>
+          </a:prstGeom>
+          <a:noFill/>
+        </p:spPr>
+        <p:txBody>
+          <a:bodyPr wrap="none">
+            <a:spAutoFit/>
+          </a:bodyPr>
+          <a:lstStyle/>
+          <a:p>
+            <a:pPr algn="l">
+              <a:defRPr sz="1000" b="0">
+                <a:solidFill>
+                  <a:srgbClr val="555555"/>
+                </a:solidFill>
+                <a:latin typeface="Arial"/>
+              </a:defRPr>
+            </a:pPr>
+            <a:r>
+              <a:t>¿Qué tal?</a:t>
+            </a:r>
+          </a:p>
+        </p:txBody>
+      </p:sp>
+      <p:sp>
+        <p:nvSpPr>
+          <p:cNvPr id="6" name="TextBox 5"/>
+          <p:cNvSpPr txBox="1"/>
+          <p:nvPr/>
+        </p:nvSpPr>
+        <p:spPr>
+          <a:xfrm>
+            <a:off x="9144000" y="6601968"/>
+            <a:ext cx="2743200" cy="228600"/>
+          </a:xfrm>
+          <a:prstGeom prst="rect">
+            <a:avLst/>
+          </a:prstGeom>
+          <a:noFill/>
+        </p:spPr>
+        <p:txBody>
+          <a:bodyPr wrap="none">
+            <a:spAutoFit/>
+          </a:bodyPr>
+          <a:lstStyle/>
+          <a:p>
+            <a:pPr algn="r">
+              <a:defRPr sz="1000" b="0">
+                <a:solidFill>
+                  <a:srgbClr val="555555"/>
+                </a:solidFill>
+                <a:latin typeface="Arial"/>
+              </a:defRPr>
+            </a:pPr>
+            <a:r>
+              <a:t>Sequenz 1</a:t>
+            </a:r>
+          </a:p>
+        </p:txBody>
+      </p:sp>
+      <p:sp>
+        <p:nvSpPr>
+          <p:cNvPr id="7" name="TextBox 6"/>
+          <p:cNvSpPr txBox="1"/>
+          <p:nvPr/>
+        </p:nvSpPr>
+        <p:spPr>
+          <a:xfrm>
+            <a:off x="457200" y="640080"/>
+            <a:ext cx="11274552" cy="731520"/>
+          </a:xfrm>
+          <a:prstGeom prst="rect">
+            <a:avLst/>
+          </a:prstGeom>
+          <a:noFill/>
+        </p:spPr>
+        <p:txBody>
+          <a:bodyPr wrap="none">
+            <a:spAutoFit/>
+          </a:bodyPr>
+          <a:lstStyle/>
+          <a:p>
+            <a:pPr algn="l">
+              <a:defRPr sz="3200" b="1">
+                <a:solidFill>
+                  <a:srgbClr val="C41E3A"/>
+                </a:solidFill>
+                <a:latin typeface="Arial"/>
+              </a:defRPr>
+            </a:pPr>
+            <a:r>
+              <a:t>Tipps für den Test</a:t>
+            </a:r>
+          </a:p>
+        </p:txBody>
+      </p:sp>
+      <p:sp>
+        <p:nvSpPr>
+          <p:cNvPr id="8" name="TextBox 7"/>
+          <p:cNvSpPr txBox="1"/>
+          <p:nvPr/>
+        </p:nvSpPr>
+        <p:spPr>
+          <a:xfrm>
+            <a:off x="640080" y="1463040"/>
+            <a:ext cx="10972800" cy="548640"/>
+          </a:xfrm>
+          <a:prstGeom prst="rect">
+            <a:avLst/>
+          </a:prstGeom>
+          <a:noFill/>
+        </p:spPr>
+        <p:txBody>
+          <a:bodyPr wrap="none">
+            <a:spAutoFit/>
+          </a:bodyPr>
+          <a:lstStyle/>
+          <a:p>
+            <a:pPr algn="l">
+              <a:defRPr sz="2000" b="0">
+                <a:solidFill>
+                  <a:srgbClr val="222222"/>
+                </a:solidFill>
+                <a:latin typeface="Arial"/>
+              </a:defRPr>
+            </a:pPr>
+            <a:r>
+              <a:t>Begrüßungen nach Tageszeit unterscheiden</a:t>
+            </a:r>
+          </a:p>
+        </p:txBody>
+      </p:sp>
+      <p:sp>
+        <p:nvSpPr>
+          <p:cNvPr id="9" name="TextBox 8"/>
+          <p:cNvSpPr txBox="1"/>
+          <p:nvPr/>
+        </p:nvSpPr>
+        <p:spPr>
+          <a:xfrm>
+            <a:off x="640080" y="2194560"/>
+            <a:ext cx="10972800" cy="548640"/>
+          </a:xfrm>
+          <a:prstGeom prst="rect">
+            <a:avLst/>
+          </a:prstGeom>
+          <a:noFill/>
+        </p:spPr>
+        <p:txBody>
+          <a:bodyPr wrap="none">
+            <a:spAutoFit/>
+          </a:bodyPr>
+          <a:lstStyle/>
+          <a:p>
+            <a:pPr algn="l">
+              <a:defRPr sz="2000" b="0">
+                <a:solidFill>
+                  <a:srgbClr val="222222"/>
+                </a:solidFill>
+                <a:latin typeface="Arial"/>
+              </a:defRPr>
+            </a:pPr>
+            <a:r>
+              <a:t>ser-Formen sicher können</a:t>
+            </a:r>
+          </a:p>
+        </p:txBody>
+      </p:sp>
+      <p:sp>
+        <p:nvSpPr>
+          <p:cNvPr id="10" name="TextBox 9"/>
+          <p:cNvSpPr txBox="1"/>
+          <p:nvPr/>
+        </p:nvSpPr>
+        <p:spPr>
+          <a:xfrm>
+            <a:off x="640080" y="2926080"/>
+            <a:ext cx="10972800" cy="548640"/>
+          </a:xfrm>
+          <a:prstGeom prst="rect">
+            <a:avLst/>
+          </a:prstGeom>
+          <a:noFill/>
+        </p:spPr>
+        <p:txBody>
+          <a:bodyPr wrap="none">
+            <a:spAutoFit/>
+          </a:bodyPr>
+          <a:lstStyle/>
+          <a:p>
+            <a:pPr algn="l">
+              <a:defRPr sz="2000" b="0">
+                <a:solidFill>
+                  <a:srgbClr val="222222"/>
+                </a:solidFill>
+                <a:latin typeface="Arial"/>
+              </a:defRPr>
+            </a:pPr>
+            <a:r>
+              <a:t>Genus der Nomen beachten (el/la)</a:t>
+            </a:r>
+          </a:p>
+        </p:txBody>
+      </p:sp>
+    </p:spTree>
+  </p:cSld>
+  <p:clrMapOvr>
+    <a:masterClrMapping/>
+  </p:clrMapOvr>
+</p:sld>
+</file>
+
+<file path=ppt/slides/slide11.xml><?xml version="1.0" encoding="utf-8"?>
+<p:sld xmlns:a="http://schemas.openxmlformats.org/drawingml/2006/main" xmlns:p="http://schemas.openxmlformats.org/presentationml/2006/main" xmlns:r="http://schemas.openxmlformats.org/officeDocument/2006/relationships">
+  <p:cSld>
+    <p:spTree>
+      <p:nvGrpSpPr>
+        <p:cNvPr id="1" name=""/>
+        <p:cNvGrpSpPr/>
+        <p:nvPr/>
+      </p:nvGrpSpPr>
+      <p:grpSpPr/>
+      <p:sp>
+        <p:nvSpPr>
+          <p:cNvPr id="2" name="Rectangle 1"/>
+          <p:cNvSpPr/>
+          <p:nvPr/>
+        </p:nvSpPr>
+        <p:spPr>
+          <a:xfrm>
+            <a:off x="0" y="0"/>
+            <a:ext cx="12191695" cy="457200"/>
+          </a:xfrm>
+          <a:prstGeom prst="rect">
+            <a:avLst/>
+          </a:prstGeom>
+          <a:solidFill>
+            <a:srgbClr val="C41E3A"/>
+          </a:solidFill>
+          <a:ln>
+            <a:noFill/>
+          </a:ln>
+        </p:spPr>
+        <p:style>
+          <a:lnRef idx="1">
+            <a:schemeClr val="accent1"/>
+          </a:lnRef>
+          <a:fillRef idx="3">
+            <a:schemeClr val="accent1"/>
+          </a:fillRef>
+          <a:effectRef idx="2">
+            <a:schemeClr val="accent1"/>
+          </a:effectRef>
+          <a:fontRef idx="minor">
+            <a:schemeClr val="lt1"/>
+          </a:fontRef>
+        </p:style>
+        <p:txBody>
+          <a:bodyPr rtlCol="0" anchor="ctr"/>
+          <a:lstStyle/>
+          <a:p>
+            <a:pPr algn="ctr"/>
+          </a:p>
+        </p:txBody>
+      </p:sp>
+      <p:sp>
+        <p:nvSpPr>
+          <p:cNvPr id="3" name="TextBox 2"/>
+          <p:cNvSpPr txBox="1"/>
+          <p:nvPr/>
+        </p:nvSpPr>
+        <p:spPr>
+          <a:xfrm>
+            <a:off x="274320" y="91440"/>
+            <a:ext cx="3657600" cy="274320"/>
+          </a:xfrm>
+          <a:prstGeom prst="rect">
+            <a:avLst/>
+          </a:prstGeom>
+          <a:noFill/>
+        </p:spPr>
+        <p:txBody>
+          <a:bodyPr wrap="none">
+            <a:spAutoFit/>
+          </a:bodyPr>
+          <a:lstStyle/>
+          <a:p>
+            <a:pPr algn="l">
+              <a:defRPr sz="1400" b="1">
+                <a:solidFill>
+                  <a:srgbClr val="FFFFFF"/>
+                </a:solidFill>
+                <a:latin typeface="Arial"/>
+              </a:defRPr>
+            </a:pPr>
+            <a:r>
+              <a:t>Spanisch Klasse 7 · LP-01d</a:t>
+            </a:r>
+          </a:p>
+        </p:txBody>
+      </p:sp>
+      <p:sp>
+        <p:nvSpPr>
+          <p:cNvPr id="4" name="Rectangle 3"/>
+          <p:cNvSpPr/>
+          <p:nvPr/>
+        </p:nvSpPr>
+        <p:spPr>
+          <a:xfrm>
+            <a:off x="0" y="6583680"/>
+            <a:ext cx="12191695" cy="274320"/>
+          </a:xfrm>
+          <a:prstGeom prst="rect">
+            <a:avLst/>
+          </a:prstGeom>
+          <a:solidFill>
+            <a:srgbClr val="F5F5F5"/>
+          </a:solidFill>
+          <a:ln>
+            <a:noFill/>
+          </a:ln>
+        </p:spPr>
+        <p:style>
+          <a:lnRef idx="1">
+            <a:schemeClr val="accent1"/>
+          </a:lnRef>
+          <a:fillRef idx="3">
+            <a:schemeClr val="accent1"/>
+          </a:fillRef>
+          <a:effectRef idx="2">
+            <a:schemeClr val="accent1"/>
+          </a:effectRef>
+          <a:fontRef idx="minor">
+            <a:schemeClr val="lt1"/>
+          </a:fontRef>
+        </p:style>
+        <p:txBody>
+          <a:bodyPr rtlCol="0" anchor="ctr"/>
+          <a:lstStyle/>
+          <a:p>
+            <a:pPr algn="ctr"/>
+          </a:p>
+        </p:txBody>
+      </p:sp>
+      <p:sp>
+        <p:nvSpPr>
+          <p:cNvPr id="5" name="TextBox 4"/>
+          <p:cNvSpPr txBox="1"/>
+          <p:nvPr/>
+        </p:nvSpPr>
+        <p:spPr>
+          <a:xfrm>
+            <a:off x="274320" y="6601968"/>
+            <a:ext cx="4572000" cy="228600"/>
+          </a:xfrm>
+          <a:prstGeom prst="rect">
+            <a:avLst/>
+          </a:prstGeom>
+          <a:noFill/>
+        </p:spPr>
+        <p:txBody>
+          <a:bodyPr wrap="none">
+            <a:spAutoFit/>
+          </a:bodyPr>
+          <a:lstStyle/>
+          <a:p>
+            <a:pPr algn="l">
+              <a:defRPr sz="1000" b="0">
+                <a:solidFill>
+                  <a:srgbClr val="555555"/>
+                </a:solidFill>
+                <a:latin typeface="Arial"/>
+              </a:defRPr>
+            </a:pPr>
+            <a:r>
+              <a:t>¿Qué tal?</a:t>
+            </a:r>
+          </a:p>
+        </p:txBody>
+      </p:sp>
+      <p:sp>
+        <p:nvSpPr>
+          <p:cNvPr id="6" name="TextBox 5"/>
+          <p:cNvSpPr txBox="1"/>
+          <p:nvPr/>
+        </p:nvSpPr>
+        <p:spPr>
+          <a:xfrm>
+            <a:off x="9144000" y="6601968"/>
+            <a:ext cx="2743200" cy="228600"/>
+          </a:xfrm>
+          <a:prstGeom prst="rect">
+            <a:avLst/>
+          </a:prstGeom>
+          <a:noFill/>
+        </p:spPr>
+        <p:txBody>
+          <a:bodyPr wrap="none">
+            <a:spAutoFit/>
+          </a:bodyPr>
+          <a:lstStyle/>
+          <a:p>
+            <a:pPr algn="r">
+              <a:defRPr sz="1000" b="0">
+                <a:solidFill>
+                  <a:srgbClr val="555555"/>
+                </a:solidFill>
+                <a:latin typeface="Arial"/>
+              </a:defRPr>
+            </a:pPr>
+            <a:r>
+              <a:t>Sequenz 1</a:t>
+            </a:r>
+          </a:p>
+        </p:txBody>
+      </p:sp>
+      <p:sp>
+        <p:nvSpPr>
+          <p:cNvPr id="7" name="Rectangle 6"/>
+          <p:cNvSpPr/>
+          <p:nvPr/>
+        </p:nvSpPr>
+        <p:spPr>
+          <a:xfrm>
+            <a:off x="457200" y="640080"/>
+            <a:ext cx="1828800" cy="457200"/>
+          </a:xfrm>
+          <a:prstGeom prst="rect">
+            <a:avLst/>
+          </a:prstGeom>
+          <a:solidFill>
+            <a:srgbClr val="C41E3A"/>
+          </a:solidFill>
+          <a:ln>
+            <a:noFill/>
+          </a:ln>
+        </p:spPr>
+        <p:style>
+          <a:lnRef idx="1">
+            <a:schemeClr val="accent1"/>
+          </a:lnRef>
+          <a:fillRef idx="3">
+            <a:schemeClr val="accent1"/>
+          </a:fillRef>
+          <a:effectRef idx="2">
+            <a:schemeClr val="accent1"/>
+          </a:effectRef>
+          <a:fontRef idx="minor">
+            <a:schemeClr val="lt1"/>
+          </a:fontRef>
+        </p:style>
+        <p:txBody>
+          <a:bodyPr rtlCol="0" anchor="ctr"/>
+          <a:lstStyle/>
+          <a:p>
+            <a:pPr algn="ctr"/>
+          </a:p>
+        </p:txBody>
+      </p:sp>
+      <p:sp>
+        <p:nvSpPr>
+          <p:cNvPr id="8" name="TextBox 7"/>
+          <p:cNvSpPr txBox="1"/>
+          <p:nvPr/>
+        </p:nvSpPr>
+        <p:spPr>
+          <a:xfrm>
+            <a:off x="548640" y="713231"/>
+            <a:ext cx="1645920" cy="320040"/>
+          </a:xfrm>
+          <a:prstGeom prst="rect">
+            <a:avLst/>
+          </a:prstGeom>
+          <a:noFill/>
+        </p:spPr>
+        <p:txBody>
+          <a:bodyPr wrap="none">
+            <a:spAutoFit/>
+          </a:bodyPr>
+          <a:lstStyle/>
+          <a:p>
+            <a:pPr algn="ctr">
+              <a:defRPr sz="1400" b="1">
+                <a:solidFill>
+                  <a:srgbClr val="FFFFFF"/>
+                </a:solidFill>
+                <a:latin typeface="Arial"/>
+              </a:defRPr>
+            </a:pPr>
+            <a:r>
+              <a:t>HAUSAUFGABE</a:t>
+            </a:r>
+          </a:p>
+        </p:txBody>
+      </p:sp>
+      <p:sp>
+        <p:nvSpPr>
+          <p:cNvPr id="9" name="TextBox 8"/>
+          <p:cNvSpPr txBox="1"/>
+          <p:nvPr/>
+        </p:nvSpPr>
+        <p:spPr>
+          <a:xfrm>
+            <a:off x="457200" y="1280160"/>
+            <a:ext cx="11274552" cy="731520"/>
+          </a:xfrm>
+          <a:prstGeom prst="rect">
+            <a:avLst/>
+          </a:prstGeom>
+          <a:noFill/>
+        </p:spPr>
+        <p:txBody>
+          <a:bodyPr wrap="none">
+            <a:spAutoFit/>
+          </a:bodyPr>
+          <a:lstStyle/>
+          <a:p>
+            <a:pPr algn="l">
+              <a:defRPr sz="3200" b="1">
+                <a:solidFill>
+                  <a:srgbClr val="C41E3A"/>
+                </a:solidFill>
+                <a:latin typeface="Arial"/>
+              </a:defRPr>
+            </a:pPr>
+            <a:r>
+              <a:t>📚 Para casa</a:t>
+            </a:r>
+          </a:p>
+        </p:txBody>
+      </p:sp>
+      <p:sp>
+        <p:nvSpPr>
+          <p:cNvPr id="10" name="TextBox 9"/>
+          <p:cNvSpPr txBox="1"/>
+          <p:nvPr/>
+        </p:nvSpPr>
+        <p:spPr>
+          <a:xfrm>
+            <a:off x="640080" y="2103120"/>
+            <a:ext cx="457200" cy="457200"/>
+          </a:xfrm>
+          <a:prstGeom prst="rect">
+            <a:avLst/>
+          </a:prstGeom>
+          <a:noFill/>
+        </p:spPr>
+        <p:txBody>
+          <a:bodyPr wrap="none">
+            <a:spAutoFit/>
+          </a:bodyPr>
+          <a:lstStyle/>
+          <a:p>
+            <a:pPr algn="l">
+              <a:defRPr sz="2400" b="1">
+                <a:solidFill>
+                  <a:srgbClr val="2A7A4B"/>
+                </a:solidFill>
+                <a:latin typeface="Arial"/>
+              </a:defRPr>
+            </a:pPr>
+            <a:r>
+              <a:t>✓</a:t>
+            </a:r>
+          </a:p>
+        </p:txBody>
+      </p:sp>
+      <p:sp>
+        <p:nvSpPr>
+          <p:cNvPr id="11" name="TextBox 10"/>
+          <p:cNvSpPr txBox="1"/>
+          <p:nvPr/>
+        </p:nvSpPr>
+        <p:spPr>
+          <a:xfrm>
+            <a:off x="1188720" y="2103120"/>
+            <a:ext cx="10058400" cy="457200"/>
+          </a:xfrm>
+          <a:prstGeom prst="rect">
+            <a:avLst/>
+          </a:prstGeom>
+          <a:noFill/>
+        </p:spPr>
+        <p:txBody>
+          <a:bodyPr wrap="none">
+            <a:spAutoFit/>
+          </a:bodyPr>
+          <a:lstStyle/>
+          <a:p>
+            <a:pPr algn="l">
+              <a:defRPr sz="2000" b="0">
+                <a:solidFill>
+                  <a:srgbClr val="222222"/>
+                </a:solidFill>
+                <a:latin typeface="Arial"/>
+              </a:defRPr>
+            </a:pPr>
+            <a:r>
+              <a:t>Alle Vokabeln Seq. 1 wiederholen</a:t>
+            </a:r>
+          </a:p>
+        </p:txBody>
+      </p:sp>
+      <p:sp>
+        <p:nvSpPr>
+          <p:cNvPr id="12" name="TextBox 11"/>
+          <p:cNvSpPr txBox="1"/>
+          <p:nvPr/>
+        </p:nvSpPr>
+        <p:spPr>
+          <a:xfrm>
+            <a:off x="640080" y="2926079"/>
+            <a:ext cx="457200" cy="457200"/>
+          </a:xfrm>
+          <a:prstGeom prst="rect">
+            <a:avLst/>
+          </a:prstGeom>
+          <a:noFill/>
+        </p:spPr>
+        <p:txBody>
+          <a:bodyPr wrap="none">
+            <a:spAutoFit/>
+          </a:bodyPr>
+          <a:lstStyle/>
+          <a:p>
+            <a:pPr algn="l">
+              <a:defRPr sz="2400" b="1">
+                <a:solidFill>
+                  <a:srgbClr val="2A7A4B"/>
+                </a:solidFill>
+                <a:latin typeface="Arial"/>
+              </a:defRPr>
+            </a:pPr>
+            <a:r>
+              <a:t>✓</a:t>
+            </a:r>
+          </a:p>
+        </p:txBody>
+      </p:sp>
+      <p:sp>
+        <p:nvSpPr>
+          <p:cNvPr id="13" name="TextBox 12"/>
+          <p:cNvSpPr txBox="1"/>
+          <p:nvPr/>
+        </p:nvSpPr>
+        <p:spPr>
+          <a:xfrm>
+            <a:off x="1188720" y="2926079"/>
+            <a:ext cx="10058400" cy="457200"/>
+          </a:xfrm>
+          <a:prstGeom prst="rect">
+            <a:avLst/>
+          </a:prstGeom>
+          <a:noFill/>
+        </p:spPr>
+        <p:txBody>
+          <a:bodyPr wrap="none">
+            <a:spAutoFit/>
+          </a:bodyPr>
+          <a:lstStyle/>
+          <a:p>
+            <a:pPr algn="l">
+              <a:defRPr sz="2000" b="0">
+                <a:solidFill>
+                  <a:srgbClr val="222222"/>
+                </a:solidFill>
+                <a:latin typeface="Arial"/>
+              </a:defRPr>
+            </a:pPr>
+            <a:r>
+              <a:t>ser-Tabelle auswendig</a:t>
+            </a:r>
+          </a:p>
+        </p:txBody>
+      </p:sp>
+      <p:sp>
+        <p:nvSpPr>
+          <p:cNvPr id="14" name="TextBox 13"/>
+          <p:cNvSpPr txBox="1"/>
+          <p:nvPr/>
+        </p:nvSpPr>
+        <p:spPr>
+          <a:xfrm>
+            <a:off x="640080" y="3749039"/>
+            <a:ext cx="457200" cy="457200"/>
+          </a:xfrm>
+          <a:prstGeom prst="rect">
+            <a:avLst/>
+          </a:prstGeom>
+          <a:noFill/>
+        </p:spPr>
+        <p:txBody>
+          <a:bodyPr wrap="none">
+            <a:spAutoFit/>
+          </a:bodyPr>
+          <a:lstStyle/>
+          <a:p>
+            <a:pPr algn="l">
+              <a:defRPr sz="2400" b="1">
+                <a:solidFill>
+                  <a:srgbClr val="2A7A4B"/>
+                </a:solidFill>
+                <a:latin typeface="Arial"/>
+              </a:defRPr>
+            </a:pPr>
+            <a:r>
+              <a:t>✓</a:t>
+            </a:r>
+          </a:p>
+        </p:txBody>
+      </p:sp>
+      <p:sp>
+        <p:nvSpPr>
+          <p:cNvPr id="15" name="TextBox 14"/>
+          <p:cNvSpPr txBox="1"/>
+          <p:nvPr/>
+        </p:nvSpPr>
+        <p:spPr>
+          <a:xfrm>
+            <a:off x="1188720" y="3749039"/>
+            <a:ext cx="10058400" cy="457200"/>
+          </a:xfrm>
+          <a:prstGeom prst="rect">
+            <a:avLst/>
+          </a:prstGeom>
+          <a:noFill/>
+        </p:spPr>
+        <p:txBody>
+          <a:bodyPr wrap="none">
+            <a:spAutoFit/>
+          </a:bodyPr>
+          <a:lstStyle/>
+          <a:p>
+            <a:pPr algn="l">
+              <a:defRPr sz="2000" b="0">
+                <a:solidFill>
+                  <a:srgbClr val="222222"/>
+                </a:solidFill>
+                <a:latin typeface="Arial"/>
+              </a:defRPr>
+            </a:pPr>
+            <a:r>
+              <a:t>Artikel el/la üben</a:t>
+            </a:r>
+          </a:p>
+        </p:txBody>
+      </p:sp>
+      <p:sp>
+        <p:nvSpPr>
+          <p:cNvPr id="16" name="TextBox 15"/>
+          <p:cNvSpPr txBox="1"/>
+          <p:nvPr/>
+        </p:nvSpPr>
+        <p:spPr>
+          <a:xfrm>
+            <a:off x="457200" y="5760720"/>
+            <a:ext cx="11274552" cy="548640"/>
+          </a:xfrm>
+          <a:prstGeom prst="rect">
+            <a:avLst/>
+          </a:prstGeom>
+          <a:noFill/>
+        </p:spPr>
+        <p:txBody>
+          <a:bodyPr wrap="none">
+            <a:spAutoFit/>
+          </a:bodyPr>
+          <a:lstStyle/>
+          <a:p>
+            <a:pPr algn="ctr">
+              <a:defRPr sz="3200" b="1">
+                <a:solidFill>
+                  <a:srgbClr val="C41E3A"/>
+                </a:solidFill>
+                <a:latin typeface="Arial"/>
+              </a:defRPr>
+            </a:pPr>
+            <a:r>
+              <a:t>¡Buena suerte!</a:t>
             </a:r>
           </a:p>
         </p:txBody>
@@ -3557,7 +4499,7 @@
               </a:defRPr>
             </a:pPr>
             <a:r>
-              <a:t>Testübersicht</a:t>
+              <a:t>Sequenz 1: Rückblick</a:t>
             </a:r>
           </a:p>
         </p:txBody>
@@ -3593,7 +4535,7 @@
               </a:defRPr>
             </a:pPr>
             <a:r>
-              <a:t>Teil 1: Begrüßung (8P)</a:t>
+              <a:t>Lektion 1a: Begrüßen &amp; Verabschieden</a:t>
             </a:r>
           </a:p>
         </p:txBody>
@@ -3629,7 +4571,7 @@
               </a:defRPr>
             </a:pPr>
             <a:r>
-              <a:t>Teil 2: ser (6P)</a:t>
+              <a:t>Lektion 1b: Sich vorstellen, ser</a:t>
             </a:r>
           </a:p>
         </p:txBody>
@@ -3665,7 +4607,7 @@
               </a:defRPr>
             </a:pPr>
             <a:r>
-              <a:t>Teil 3: Artikel (6P)</a:t>
+              <a:t>Lektion 1c: Artikel, Alphabet</a:t>
             </a:r>
           </a:p>
         </p:txBody>
@@ -3913,7 +4855,7 @@
               </a:defRPr>
             </a:pPr>
             <a:r>
-              <a:t>📋 Wiederholung</a:t>
+              <a:t>📋 Vokabeln Seq. 1</a:t>
             </a:r>
           </a:p>
         </p:txBody>
@@ -3985,7 +4927,7 @@
               </a:defRPr>
             </a:pPr>
             <a:r>
-              <a:t>•  Begrüßungen</a:t>
+              <a:t>•  ¡Hola! / ¡Adiós!</a:t>
             </a:r>
           </a:p>
         </p:txBody>
@@ -4021,7 +4963,7 @@
               </a:defRPr>
             </a:pPr>
             <a:r>
-              <a:t>•  Verabschiedungen</a:t>
+              <a:t>•  Buenos días/tardes/noches</a:t>
             </a:r>
           </a:p>
         </p:txBody>
@@ -4029,6 +4971,42 @@
       <p:sp>
         <p:nvSpPr>
           <p:cNvPr id="11" name="TextBox 10"/>
+          <p:cNvSpPr txBox="1"/>
+          <p:nvPr/>
+        </p:nvSpPr>
+        <p:spPr>
+          <a:xfrm>
+            <a:off x="822960" y="3108960"/>
+            <a:ext cx="4846320" cy="457200"/>
+          </a:xfrm>
+          <a:prstGeom prst="rect">
+            <a:avLst/>
+          </a:prstGeom>
+          <a:noFill/>
+        </p:spPr>
+        <p:txBody>
+          <a:bodyPr wrap="none">
+            <a:spAutoFit/>
+          </a:bodyPr>
+          <a:lstStyle/>
+          <a:p>
+            <a:pPr algn="l">
+              <a:defRPr sz="1800" b="0">
+                <a:solidFill>
+                  <a:srgbClr val="222222"/>
+                </a:solidFill>
+                <a:latin typeface="Arial"/>
+              </a:defRPr>
+            </a:pPr>
+            <a:r>
+              <a:t>•  Me llamo... / Soy de...</a:t>
+            </a:r>
+          </a:p>
+        </p:txBody>
+      </p:sp>
+      <p:sp>
+        <p:nvSpPr>
+          <p:cNvPr id="12" name="TextBox 11"/>
           <p:cNvSpPr txBox="1"/>
           <p:nvPr/>
         </p:nvSpPr>
@@ -4064,7 +5042,7 @@
       </p:sp>
       <p:sp>
         <p:nvSpPr>
-          <p:cNvPr id="12" name="TextBox 11"/>
+          <p:cNvPr id="13" name="TextBox 12"/>
           <p:cNvSpPr txBox="1"/>
           <p:nvPr/>
         </p:nvSpPr>
@@ -4093,14 +5071,14 @@
               </a:defRPr>
             </a:pPr>
             <a:r>
-              <a:t>•  ser</a:t>
-            </a:r>
-          </a:p>
-        </p:txBody>
-      </p:sp>
-      <p:sp>
-        <p:nvSpPr>
-          <p:cNvPr id="13" name="TextBox 12"/>
+              <a:t>•  el/la/los/las</a:t>
+            </a:r>
+          </a:p>
+        </p:txBody>
+      </p:sp>
+      <p:sp>
+        <p:nvSpPr>
+          <p:cNvPr id="14" name="TextBox 13"/>
           <p:cNvSpPr txBox="1"/>
           <p:nvPr/>
         </p:nvSpPr>
@@ -4129,7 +5107,43 @@
               </a:defRPr>
             </a:pPr>
             <a:r>
-              <a:t>•  el/la/los/las</a:t>
+              <a:t>•  un/una</a:t>
+            </a:r>
+          </a:p>
+        </p:txBody>
+      </p:sp>
+      <p:sp>
+        <p:nvSpPr>
+          <p:cNvPr id="15" name="TextBox 14"/>
+          <p:cNvSpPr txBox="1"/>
+          <p:nvPr/>
+        </p:nvSpPr>
+        <p:spPr>
+          <a:xfrm>
+            <a:off x="6583680" y="3108960"/>
+            <a:ext cx="4846320" cy="457200"/>
+          </a:xfrm>
+          <a:prstGeom prst="rect">
+            <a:avLst/>
+          </a:prstGeom>
+          <a:noFill/>
+        </p:spPr>
+        <p:txBody>
+          <a:bodyPr wrap="none">
+            <a:spAutoFit/>
+          </a:bodyPr>
+          <a:lstStyle/>
+          <a:p>
+            <a:pPr algn="l">
+              <a:defRPr sz="1800" b="0">
+                <a:solidFill>
+                  <a:srgbClr val="222222"/>
+                </a:solidFill>
+                <a:latin typeface="Arial"/>
+              </a:defRPr>
+            </a:pPr>
+            <a:r>
+              <a:t>•  español/a, alemán/a</a:t>
             </a:r>
           </a:p>
         </p:txBody>
@@ -4348,14 +5362,356 @@
       </p:sp>
       <p:sp>
         <p:nvSpPr>
-          <p:cNvPr id="7" name="Rectangle 6"/>
+          <p:cNvPr id="7" name="TextBox 6"/>
+          <p:cNvSpPr txBox="1"/>
+          <p:nvPr/>
+        </p:nvSpPr>
+        <p:spPr>
+          <a:xfrm>
+            <a:off x="457200" y="640080"/>
+            <a:ext cx="11274552" cy="731520"/>
+          </a:xfrm>
+          <a:prstGeom prst="rect">
+            <a:avLst/>
+          </a:prstGeom>
+          <a:noFill/>
+        </p:spPr>
+        <p:txBody>
+          <a:bodyPr wrap="none">
+            <a:spAutoFit/>
+          </a:bodyPr>
+          <a:lstStyle/>
+          <a:p>
+            <a:pPr algn="l">
+              <a:defRPr sz="3200" b="1">
+                <a:solidFill>
+                  <a:srgbClr val="C41E3A"/>
+                </a:solidFill>
+                <a:latin typeface="Arial"/>
+              </a:defRPr>
+            </a:pPr>
+            <a:r>
+              <a:t>📝 Grammatik: ser</a:t>
+            </a:r>
+          </a:p>
+        </p:txBody>
+      </p:sp>
+      <p:sp>
+        <p:nvSpPr>
+          <p:cNvPr id="8" name="TextBox 7"/>
+          <p:cNvSpPr txBox="1"/>
+          <p:nvPr/>
+        </p:nvSpPr>
+        <p:spPr>
+          <a:xfrm>
+            <a:off x="640080" y="1463040"/>
+            <a:ext cx="5029200" cy="731520"/>
+          </a:xfrm>
+          <a:prstGeom prst="rect">
+            <a:avLst/>
+          </a:prstGeom>
+          <a:noFill/>
+        </p:spPr>
+        <p:txBody>
+          <a:bodyPr wrap="none">
+            <a:spAutoFit/>
+          </a:bodyPr>
+          <a:lstStyle/>
+          <a:p>
+            <a:pPr algn="l">
+              <a:defRPr sz="2800" b="1">
+                <a:solidFill>
+                  <a:srgbClr val="C41E3A"/>
+                </a:solidFill>
+                <a:latin typeface="Arial"/>
+              </a:defRPr>
+            </a:pPr>
+            <a:r>
+              <a:t>yo soy</a:t>
+            </a:r>
+          </a:p>
+        </p:txBody>
+      </p:sp>
+      <p:sp>
+        <p:nvSpPr>
+          <p:cNvPr id="9" name="TextBox 8"/>
+          <p:cNvSpPr txBox="1"/>
+          <p:nvPr/>
+        </p:nvSpPr>
+        <p:spPr>
+          <a:xfrm>
+            <a:off x="5943600" y="1554480"/>
+            <a:ext cx="5486400" cy="548640"/>
+          </a:xfrm>
+          <a:prstGeom prst="rect">
+            <a:avLst/>
+          </a:prstGeom>
+          <a:noFill/>
+        </p:spPr>
+        <p:txBody>
+          <a:bodyPr wrap="none">
+            <a:spAutoFit/>
+          </a:bodyPr>
+          <a:lstStyle/>
+          <a:p>
+            <a:pPr algn="l">
+              <a:defRPr sz="1800" b="0">
+                <a:solidFill>
+                  <a:srgbClr val="555555"/>
+                </a:solidFill>
+                <a:latin typeface="Arial"/>
+              </a:defRPr>
+            </a:pPr>
+            <a:r>
+              <a:t>ich bin</a:t>
+            </a:r>
+          </a:p>
+        </p:txBody>
+      </p:sp>
+      <p:sp>
+        <p:nvSpPr>
+          <p:cNvPr id="10" name="TextBox 9"/>
+          <p:cNvSpPr txBox="1"/>
+          <p:nvPr/>
+        </p:nvSpPr>
+        <p:spPr>
+          <a:xfrm>
+            <a:off x="640080" y="2560320"/>
+            <a:ext cx="5029200" cy="731520"/>
+          </a:xfrm>
+          <a:prstGeom prst="rect">
+            <a:avLst/>
+          </a:prstGeom>
+          <a:noFill/>
+        </p:spPr>
+        <p:txBody>
+          <a:bodyPr wrap="none">
+            <a:spAutoFit/>
+          </a:bodyPr>
+          <a:lstStyle/>
+          <a:p>
+            <a:pPr algn="l">
+              <a:defRPr sz="2800" b="1">
+                <a:solidFill>
+                  <a:srgbClr val="C41E3A"/>
+                </a:solidFill>
+                <a:latin typeface="Arial"/>
+              </a:defRPr>
+            </a:pPr>
+            <a:r>
+              <a:t>tú eres</a:t>
+            </a:r>
+          </a:p>
+        </p:txBody>
+      </p:sp>
+      <p:sp>
+        <p:nvSpPr>
+          <p:cNvPr id="11" name="TextBox 10"/>
+          <p:cNvSpPr txBox="1"/>
+          <p:nvPr/>
+        </p:nvSpPr>
+        <p:spPr>
+          <a:xfrm>
+            <a:off x="5943600" y="2651760"/>
+            <a:ext cx="5486400" cy="548640"/>
+          </a:xfrm>
+          <a:prstGeom prst="rect">
+            <a:avLst/>
+          </a:prstGeom>
+          <a:noFill/>
+        </p:spPr>
+        <p:txBody>
+          <a:bodyPr wrap="none">
+            <a:spAutoFit/>
+          </a:bodyPr>
+          <a:lstStyle/>
+          <a:p>
+            <a:pPr algn="l">
+              <a:defRPr sz="1800" b="0">
+                <a:solidFill>
+                  <a:srgbClr val="555555"/>
+                </a:solidFill>
+                <a:latin typeface="Arial"/>
+              </a:defRPr>
+            </a:pPr>
+            <a:r>
+              <a:t>du bist</a:t>
+            </a:r>
+          </a:p>
+        </p:txBody>
+      </p:sp>
+      <p:sp>
+        <p:nvSpPr>
+          <p:cNvPr id="12" name="TextBox 11"/>
+          <p:cNvSpPr txBox="1"/>
+          <p:nvPr/>
+        </p:nvSpPr>
+        <p:spPr>
+          <a:xfrm>
+            <a:off x="640080" y="3657600"/>
+            <a:ext cx="5029200" cy="731520"/>
+          </a:xfrm>
+          <a:prstGeom prst="rect">
+            <a:avLst/>
+          </a:prstGeom>
+          <a:noFill/>
+        </p:spPr>
+        <p:txBody>
+          <a:bodyPr wrap="none">
+            <a:spAutoFit/>
+          </a:bodyPr>
+          <a:lstStyle/>
+          <a:p>
+            <a:pPr algn="l">
+              <a:defRPr sz="2800" b="1">
+                <a:solidFill>
+                  <a:srgbClr val="C41E3A"/>
+                </a:solidFill>
+                <a:latin typeface="Arial"/>
+              </a:defRPr>
+            </a:pPr>
+            <a:r>
+              <a:t>él/ella es</a:t>
+            </a:r>
+          </a:p>
+        </p:txBody>
+      </p:sp>
+      <p:sp>
+        <p:nvSpPr>
+          <p:cNvPr id="13" name="TextBox 12"/>
+          <p:cNvSpPr txBox="1"/>
+          <p:nvPr/>
+        </p:nvSpPr>
+        <p:spPr>
+          <a:xfrm>
+            <a:off x="5943600" y="3749039"/>
+            <a:ext cx="5486400" cy="548640"/>
+          </a:xfrm>
+          <a:prstGeom prst="rect">
+            <a:avLst/>
+          </a:prstGeom>
+          <a:noFill/>
+        </p:spPr>
+        <p:txBody>
+          <a:bodyPr wrap="none">
+            <a:spAutoFit/>
+          </a:bodyPr>
+          <a:lstStyle/>
+          <a:p>
+            <a:pPr algn="l">
+              <a:defRPr sz="1800" b="0">
+                <a:solidFill>
+                  <a:srgbClr val="555555"/>
+                </a:solidFill>
+                <a:latin typeface="Arial"/>
+              </a:defRPr>
+            </a:pPr>
+            <a:r>
+              <a:t>er/sie ist</a:t>
+            </a:r>
+          </a:p>
+        </p:txBody>
+      </p:sp>
+      <p:sp>
+        <p:nvSpPr>
+          <p:cNvPr id="14" name="TextBox 13"/>
+          <p:cNvSpPr txBox="1"/>
+          <p:nvPr/>
+        </p:nvSpPr>
+        <p:spPr>
+          <a:xfrm>
+            <a:off x="640080" y="4754880"/>
+            <a:ext cx="5029200" cy="731520"/>
+          </a:xfrm>
+          <a:prstGeom prst="rect">
+            <a:avLst/>
+          </a:prstGeom>
+          <a:noFill/>
+        </p:spPr>
+        <p:txBody>
+          <a:bodyPr wrap="none">
+            <a:spAutoFit/>
+          </a:bodyPr>
+          <a:lstStyle/>
+          <a:p>
+            <a:pPr algn="l">
+              <a:defRPr sz="2800" b="1">
+                <a:solidFill>
+                  <a:srgbClr val="C41E3A"/>
+                </a:solidFill>
+                <a:latin typeface="Arial"/>
+              </a:defRPr>
+            </a:pPr>
+            <a:r>
+              <a:t>nosotros somos</a:t>
+            </a:r>
+          </a:p>
+        </p:txBody>
+      </p:sp>
+      <p:sp>
+        <p:nvSpPr>
+          <p:cNvPr id="15" name="TextBox 14"/>
+          <p:cNvSpPr txBox="1"/>
+          <p:nvPr/>
+        </p:nvSpPr>
+        <p:spPr>
+          <a:xfrm>
+            <a:off x="5943600" y="4846320"/>
+            <a:ext cx="5486400" cy="548640"/>
+          </a:xfrm>
+          <a:prstGeom prst="rect">
+            <a:avLst/>
+          </a:prstGeom>
+          <a:noFill/>
+        </p:spPr>
+        <p:txBody>
+          <a:bodyPr wrap="none">
+            <a:spAutoFit/>
+          </a:bodyPr>
+          <a:lstStyle/>
+          <a:p>
+            <a:pPr algn="l">
+              <a:defRPr sz="1800" b="0">
+                <a:solidFill>
+                  <a:srgbClr val="555555"/>
+                </a:solidFill>
+                <a:latin typeface="Arial"/>
+              </a:defRPr>
+            </a:pPr>
+            <a:r>
+              <a:t>wir sind</a:t>
+            </a:r>
+          </a:p>
+        </p:txBody>
+      </p:sp>
+    </p:spTree>
+  </p:cSld>
+  <p:clrMapOvr>
+    <a:masterClrMapping/>
+  </p:clrMapOvr>
+</p:sld>
+</file>
+
+<file path=ppt/slides/slide5.xml><?xml version="1.0" encoding="utf-8"?>
+<p:sld xmlns:a="http://schemas.openxmlformats.org/drawingml/2006/main" xmlns:p="http://schemas.openxmlformats.org/presentationml/2006/main" xmlns:r="http://schemas.openxmlformats.org/officeDocument/2006/relationships">
+  <p:cSld>
+    <p:spTree>
+      <p:nvGrpSpPr>
+        <p:cNvPr id="1" name=""/>
+        <p:cNvGrpSpPr/>
+        <p:nvPr/>
+      </p:nvGrpSpPr>
+      <p:grpSpPr/>
+      <p:sp>
+        <p:nvSpPr>
+          <p:cNvPr id="2" name="Rectangle 1"/>
           <p:cNvSpPr/>
           <p:nvPr/>
         </p:nvSpPr>
         <p:spPr>
           <a:xfrm>
-            <a:off x="457200" y="640080"/>
-            <a:ext cx="1828800" cy="457200"/>
+            <a:off x="0" y="0"/>
+            <a:ext cx="12191695" cy="457200"/>
           </a:xfrm>
           <a:prstGeom prst="rect">
             <a:avLst/>
@@ -4391,6 +5747,1056 @@
       </p:sp>
       <p:sp>
         <p:nvSpPr>
+          <p:cNvPr id="3" name="TextBox 2"/>
+          <p:cNvSpPr txBox="1"/>
+          <p:nvPr/>
+        </p:nvSpPr>
+        <p:spPr>
+          <a:xfrm>
+            <a:off x="274320" y="91440"/>
+            <a:ext cx="3657600" cy="274320"/>
+          </a:xfrm>
+          <a:prstGeom prst="rect">
+            <a:avLst/>
+          </a:prstGeom>
+          <a:noFill/>
+        </p:spPr>
+        <p:txBody>
+          <a:bodyPr wrap="none">
+            <a:spAutoFit/>
+          </a:bodyPr>
+          <a:lstStyle/>
+          <a:p>
+            <a:pPr algn="l">
+              <a:defRPr sz="1400" b="1">
+                <a:solidFill>
+                  <a:srgbClr val="FFFFFF"/>
+                </a:solidFill>
+                <a:latin typeface="Arial"/>
+              </a:defRPr>
+            </a:pPr>
+            <a:r>
+              <a:t>Spanisch Klasse 7 · LP-01d</a:t>
+            </a:r>
+          </a:p>
+        </p:txBody>
+      </p:sp>
+      <p:sp>
+        <p:nvSpPr>
+          <p:cNvPr id="4" name="Rectangle 3"/>
+          <p:cNvSpPr/>
+          <p:nvPr/>
+        </p:nvSpPr>
+        <p:spPr>
+          <a:xfrm>
+            <a:off x="0" y="6583680"/>
+            <a:ext cx="12191695" cy="274320"/>
+          </a:xfrm>
+          <a:prstGeom prst="rect">
+            <a:avLst/>
+          </a:prstGeom>
+          <a:solidFill>
+            <a:srgbClr val="F5F5F5"/>
+          </a:solidFill>
+          <a:ln>
+            <a:noFill/>
+          </a:ln>
+        </p:spPr>
+        <p:style>
+          <a:lnRef idx="1">
+            <a:schemeClr val="accent1"/>
+          </a:lnRef>
+          <a:fillRef idx="3">
+            <a:schemeClr val="accent1"/>
+          </a:fillRef>
+          <a:effectRef idx="2">
+            <a:schemeClr val="accent1"/>
+          </a:effectRef>
+          <a:fontRef idx="minor">
+            <a:schemeClr val="lt1"/>
+          </a:fontRef>
+        </p:style>
+        <p:txBody>
+          <a:bodyPr rtlCol="0" anchor="ctr"/>
+          <a:lstStyle/>
+          <a:p>
+            <a:pPr algn="ctr"/>
+          </a:p>
+        </p:txBody>
+      </p:sp>
+      <p:sp>
+        <p:nvSpPr>
+          <p:cNvPr id="5" name="TextBox 4"/>
+          <p:cNvSpPr txBox="1"/>
+          <p:nvPr/>
+        </p:nvSpPr>
+        <p:spPr>
+          <a:xfrm>
+            <a:off x="274320" y="6601968"/>
+            <a:ext cx="4572000" cy="228600"/>
+          </a:xfrm>
+          <a:prstGeom prst="rect">
+            <a:avLst/>
+          </a:prstGeom>
+          <a:noFill/>
+        </p:spPr>
+        <p:txBody>
+          <a:bodyPr wrap="none">
+            <a:spAutoFit/>
+          </a:bodyPr>
+          <a:lstStyle/>
+          <a:p>
+            <a:pPr algn="l">
+              <a:defRPr sz="1000" b="0">
+                <a:solidFill>
+                  <a:srgbClr val="555555"/>
+                </a:solidFill>
+                <a:latin typeface="Arial"/>
+              </a:defRPr>
+            </a:pPr>
+            <a:r>
+              <a:t>¿Qué tal?</a:t>
+            </a:r>
+          </a:p>
+        </p:txBody>
+      </p:sp>
+      <p:sp>
+        <p:nvSpPr>
+          <p:cNvPr id="6" name="TextBox 5"/>
+          <p:cNvSpPr txBox="1"/>
+          <p:nvPr/>
+        </p:nvSpPr>
+        <p:spPr>
+          <a:xfrm>
+            <a:off x="9144000" y="6601968"/>
+            <a:ext cx="2743200" cy="228600"/>
+          </a:xfrm>
+          <a:prstGeom prst="rect">
+            <a:avLst/>
+          </a:prstGeom>
+          <a:noFill/>
+        </p:spPr>
+        <p:txBody>
+          <a:bodyPr wrap="none">
+            <a:spAutoFit/>
+          </a:bodyPr>
+          <a:lstStyle/>
+          <a:p>
+            <a:pPr algn="r">
+              <a:defRPr sz="1000" b="0">
+                <a:solidFill>
+                  <a:srgbClr val="555555"/>
+                </a:solidFill>
+                <a:latin typeface="Arial"/>
+              </a:defRPr>
+            </a:pPr>
+            <a:r>
+              <a:t>Sequenz 1</a:t>
+            </a:r>
+          </a:p>
+        </p:txBody>
+      </p:sp>
+      <p:sp>
+        <p:nvSpPr>
+          <p:cNvPr id="7" name="TextBox 6"/>
+          <p:cNvSpPr txBox="1"/>
+          <p:nvPr/>
+        </p:nvSpPr>
+        <p:spPr>
+          <a:xfrm>
+            <a:off x="457200" y="640080"/>
+            <a:ext cx="11274552" cy="731520"/>
+          </a:xfrm>
+          <a:prstGeom prst="rect">
+            <a:avLst/>
+          </a:prstGeom>
+          <a:noFill/>
+        </p:spPr>
+        <p:txBody>
+          <a:bodyPr wrap="none">
+            <a:spAutoFit/>
+          </a:bodyPr>
+          <a:lstStyle/>
+          <a:p>
+            <a:pPr algn="l">
+              <a:defRPr sz="3200" b="1">
+                <a:solidFill>
+                  <a:srgbClr val="C41E3A"/>
+                </a:solidFill>
+                <a:latin typeface="Arial"/>
+              </a:defRPr>
+            </a:pPr>
+            <a:r>
+              <a:t>📝 Grammatik: Artikel</a:t>
+            </a:r>
+          </a:p>
+        </p:txBody>
+      </p:sp>
+      <p:sp>
+        <p:nvSpPr>
+          <p:cNvPr id="8" name="TextBox 7"/>
+          <p:cNvSpPr txBox="1"/>
+          <p:nvPr/>
+        </p:nvSpPr>
+        <p:spPr>
+          <a:xfrm>
+            <a:off x="640080" y="1463040"/>
+            <a:ext cx="5029200" cy="731520"/>
+          </a:xfrm>
+          <a:prstGeom prst="rect">
+            <a:avLst/>
+          </a:prstGeom>
+          <a:noFill/>
+        </p:spPr>
+        <p:txBody>
+          <a:bodyPr wrap="none">
+            <a:spAutoFit/>
+          </a:bodyPr>
+          <a:lstStyle/>
+          <a:p>
+            <a:pPr algn="l">
+              <a:defRPr sz="2800" b="1">
+                <a:solidFill>
+                  <a:srgbClr val="C41E3A"/>
+                </a:solidFill>
+                <a:latin typeface="Arial"/>
+              </a:defRPr>
+            </a:pPr>
+            <a:r>
+              <a:t>el/los</a:t>
+            </a:r>
+          </a:p>
+        </p:txBody>
+      </p:sp>
+      <p:sp>
+        <p:nvSpPr>
+          <p:cNvPr id="9" name="TextBox 8"/>
+          <p:cNvSpPr txBox="1"/>
+          <p:nvPr/>
+        </p:nvSpPr>
+        <p:spPr>
+          <a:xfrm>
+            <a:off x="5943600" y="1554480"/>
+            <a:ext cx="5486400" cy="548640"/>
+          </a:xfrm>
+          <a:prstGeom prst="rect">
+            <a:avLst/>
+          </a:prstGeom>
+          <a:noFill/>
+        </p:spPr>
+        <p:txBody>
+          <a:bodyPr wrap="none">
+            <a:spAutoFit/>
+          </a:bodyPr>
+          <a:lstStyle/>
+          <a:p>
+            <a:pPr algn="l">
+              <a:defRPr sz="1800" b="0">
+                <a:solidFill>
+                  <a:srgbClr val="555555"/>
+                </a:solidFill>
+                <a:latin typeface="Arial"/>
+              </a:defRPr>
+            </a:pPr>
+            <a:r>
+              <a:t>maskulin</a:t>
+            </a:r>
+          </a:p>
+        </p:txBody>
+      </p:sp>
+      <p:sp>
+        <p:nvSpPr>
+          <p:cNvPr id="10" name="TextBox 9"/>
+          <p:cNvSpPr txBox="1"/>
+          <p:nvPr/>
+        </p:nvSpPr>
+        <p:spPr>
+          <a:xfrm>
+            <a:off x="640080" y="2560320"/>
+            <a:ext cx="5029200" cy="731520"/>
+          </a:xfrm>
+          <a:prstGeom prst="rect">
+            <a:avLst/>
+          </a:prstGeom>
+          <a:noFill/>
+        </p:spPr>
+        <p:txBody>
+          <a:bodyPr wrap="none">
+            <a:spAutoFit/>
+          </a:bodyPr>
+          <a:lstStyle/>
+          <a:p>
+            <a:pPr algn="l">
+              <a:defRPr sz="2800" b="1">
+                <a:solidFill>
+                  <a:srgbClr val="C41E3A"/>
+                </a:solidFill>
+                <a:latin typeface="Arial"/>
+              </a:defRPr>
+            </a:pPr>
+            <a:r>
+              <a:t>la/las</a:t>
+            </a:r>
+          </a:p>
+        </p:txBody>
+      </p:sp>
+      <p:sp>
+        <p:nvSpPr>
+          <p:cNvPr id="11" name="TextBox 10"/>
+          <p:cNvSpPr txBox="1"/>
+          <p:nvPr/>
+        </p:nvSpPr>
+        <p:spPr>
+          <a:xfrm>
+            <a:off x="5943600" y="2651760"/>
+            <a:ext cx="5486400" cy="548640"/>
+          </a:xfrm>
+          <a:prstGeom prst="rect">
+            <a:avLst/>
+          </a:prstGeom>
+          <a:noFill/>
+        </p:spPr>
+        <p:txBody>
+          <a:bodyPr wrap="none">
+            <a:spAutoFit/>
+          </a:bodyPr>
+          <a:lstStyle/>
+          <a:p>
+            <a:pPr algn="l">
+              <a:defRPr sz="1800" b="0">
+                <a:solidFill>
+                  <a:srgbClr val="555555"/>
+                </a:solidFill>
+                <a:latin typeface="Arial"/>
+              </a:defRPr>
+            </a:pPr>
+            <a:r>
+              <a:t>feminin</a:t>
+            </a:r>
+          </a:p>
+        </p:txBody>
+      </p:sp>
+      <p:sp>
+        <p:nvSpPr>
+          <p:cNvPr id="12" name="TextBox 11"/>
+          <p:cNvSpPr txBox="1"/>
+          <p:nvPr/>
+        </p:nvSpPr>
+        <p:spPr>
+          <a:xfrm>
+            <a:off x="640080" y="3657600"/>
+            <a:ext cx="5029200" cy="731520"/>
+          </a:xfrm>
+          <a:prstGeom prst="rect">
+            <a:avLst/>
+          </a:prstGeom>
+          <a:noFill/>
+        </p:spPr>
+        <p:txBody>
+          <a:bodyPr wrap="none">
+            <a:spAutoFit/>
+          </a:bodyPr>
+          <a:lstStyle/>
+          <a:p>
+            <a:pPr algn="l">
+              <a:defRPr sz="2800" b="1">
+                <a:solidFill>
+                  <a:srgbClr val="C41E3A"/>
+                </a:solidFill>
+                <a:latin typeface="Arial"/>
+              </a:defRPr>
+            </a:pPr>
+            <a:r>
+              <a:t>un/una</a:t>
+            </a:r>
+          </a:p>
+        </p:txBody>
+      </p:sp>
+      <p:sp>
+        <p:nvSpPr>
+          <p:cNvPr id="13" name="TextBox 12"/>
+          <p:cNvSpPr txBox="1"/>
+          <p:nvPr/>
+        </p:nvSpPr>
+        <p:spPr>
+          <a:xfrm>
+            <a:off x="5943600" y="3749039"/>
+            <a:ext cx="5486400" cy="548640"/>
+          </a:xfrm>
+          <a:prstGeom prst="rect">
+            <a:avLst/>
+          </a:prstGeom>
+          <a:noFill/>
+        </p:spPr>
+        <p:txBody>
+          <a:bodyPr wrap="none">
+            <a:spAutoFit/>
+          </a:bodyPr>
+          <a:lstStyle/>
+          <a:p>
+            <a:pPr algn="l">
+              <a:defRPr sz="1800" b="0">
+                <a:solidFill>
+                  <a:srgbClr val="555555"/>
+                </a:solidFill>
+                <a:latin typeface="Arial"/>
+              </a:defRPr>
+            </a:pPr>
+            <a:r>
+              <a:t>unbestimmt</a:t>
+            </a:r>
+          </a:p>
+        </p:txBody>
+      </p:sp>
+    </p:spTree>
+  </p:cSld>
+  <p:clrMapOvr>
+    <a:masterClrMapping/>
+  </p:clrMapOvr>
+</p:sld>
+</file>
+
+<file path=ppt/slides/slide6.xml><?xml version="1.0" encoding="utf-8"?>
+<p:sld xmlns:a="http://schemas.openxmlformats.org/drawingml/2006/main" xmlns:p="http://schemas.openxmlformats.org/presentationml/2006/main" xmlns:r="http://schemas.openxmlformats.org/officeDocument/2006/relationships">
+  <p:cSld>
+    <p:spTree>
+      <p:nvGrpSpPr>
+        <p:cNvPr id="1" name=""/>
+        <p:cNvGrpSpPr/>
+        <p:nvPr/>
+      </p:nvGrpSpPr>
+      <p:grpSpPr/>
+      <p:sp>
+        <p:nvSpPr>
+          <p:cNvPr id="2" name="Rectangle 1"/>
+          <p:cNvSpPr/>
+          <p:nvPr/>
+        </p:nvSpPr>
+        <p:spPr>
+          <a:xfrm>
+            <a:off x="0" y="0"/>
+            <a:ext cx="12191695" cy="457200"/>
+          </a:xfrm>
+          <a:prstGeom prst="rect">
+            <a:avLst/>
+          </a:prstGeom>
+          <a:solidFill>
+            <a:srgbClr val="C41E3A"/>
+          </a:solidFill>
+          <a:ln>
+            <a:noFill/>
+          </a:ln>
+        </p:spPr>
+        <p:style>
+          <a:lnRef idx="1">
+            <a:schemeClr val="accent1"/>
+          </a:lnRef>
+          <a:fillRef idx="3">
+            <a:schemeClr val="accent1"/>
+          </a:fillRef>
+          <a:effectRef idx="2">
+            <a:schemeClr val="accent1"/>
+          </a:effectRef>
+          <a:fontRef idx="minor">
+            <a:schemeClr val="lt1"/>
+          </a:fontRef>
+        </p:style>
+        <p:txBody>
+          <a:bodyPr rtlCol="0" anchor="ctr"/>
+          <a:lstStyle/>
+          <a:p>
+            <a:pPr algn="ctr"/>
+          </a:p>
+        </p:txBody>
+      </p:sp>
+      <p:sp>
+        <p:nvSpPr>
+          <p:cNvPr id="3" name="TextBox 2"/>
+          <p:cNvSpPr txBox="1"/>
+          <p:nvPr/>
+        </p:nvSpPr>
+        <p:spPr>
+          <a:xfrm>
+            <a:off x="274320" y="91440"/>
+            <a:ext cx="3657600" cy="274320"/>
+          </a:xfrm>
+          <a:prstGeom prst="rect">
+            <a:avLst/>
+          </a:prstGeom>
+          <a:noFill/>
+        </p:spPr>
+        <p:txBody>
+          <a:bodyPr wrap="none">
+            <a:spAutoFit/>
+          </a:bodyPr>
+          <a:lstStyle/>
+          <a:p>
+            <a:pPr algn="l">
+              <a:defRPr sz="1400" b="1">
+                <a:solidFill>
+                  <a:srgbClr val="FFFFFF"/>
+                </a:solidFill>
+                <a:latin typeface="Arial"/>
+              </a:defRPr>
+            </a:pPr>
+            <a:r>
+              <a:t>Spanisch Klasse 7 · LP-01d</a:t>
+            </a:r>
+          </a:p>
+        </p:txBody>
+      </p:sp>
+      <p:sp>
+        <p:nvSpPr>
+          <p:cNvPr id="4" name="Rectangle 3"/>
+          <p:cNvSpPr/>
+          <p:nvPr/>
+        </p:nvSpPr>
+        <p:spPr>
+          <a:xfrm>
+            <a:off x="0" y="6583680"/>
+            <a:ext cx="12191695" cy="274320"/>
+          </a:xfrm>
+          <a:prstGeom prst="rect">
+            <a:avLst/>
+          </a:prstGeom>
+          <a:solidFill>
+            <a:srgbClr val="F5F5F5"/>
+          </a:solidFill>
+          <a:ln>
+            <a:noFill/>
+          </a:ln>
+        </p:spPr>
+        <p:style>
+          <a:lnRef idx="1">
+            <a:schemeClr val="accent1"/>
+          </a:lnRef>
+          <a:fillRef idx="3">
+            <a:schemeClr val="accent1"/>
+          </a:fillRef>
+          <a:effectRef idx="2">
+            <a:schemeClr val="accent1"/>
+          </a:effectRef>
+          <a:fontRef idx="minor">
+            <a:schemeClr val="lt1"/>
+          </a:fontRef>
+        </p:style>
+        <p:txBody>
+          <a:bodyPr rtlCol="0" anchor="ctr"/>
+          <a:lstStyle/>
+          <a:p>
+            <a:pPr algn="ctr"/>
+          </a:p>
+        </p:txBody>
+      </p:sp>
+      <p:sp>
+        <p:nvSpPr>
+          <p:cNvPr id="5" name="TextBox 4"/>
+          <p:cNvSpPr txBox="1"/>
+          <p:nvPr/>
+        </p:nvSpPr>
+        <p:spPr>
+          <a:xfrm>
+            <a:off x="274320" y="6601968"/>
+            <a:ext cx="4572000" cy="228600"/>
+          </a:xfrm>
+          <a:prstGeom prst="rect">
+            <a:avLst/>
+          </a:prstGeom>
+          <a:noFill/>
+        </p:spPr>
+        <p:txBody>
+          <a:bodyPr wrap="none">
+            <a:spAutoFit/>
+          </a:bodyPr>
+          <a:lstStyle/>
+          <a:p>
+            <a:pPr algn="l">
+              <a:defRPr sz="1000" b="0">
+                <a:solidFill>
+                  <a:srgbClr val="555555"/>
+                </a:solidFill>
+                <a:latin typeface="Arial"/>
+              </a:defRPr>
+            </a:pPr>
+            <a:r>
+              <a:t>¿Qué tal?</a:t>
+            </a:r>
+          </a:p>
+        </p:txBody>
+      </p:sp>
+      <p:sp>
+        <p:nvSpPr>
+          <p:cNvPr id="6" name="TextBox 5"/>
+          <p:cNvSpPr txBox="1"/>
+          <p:nvPr/>
+        </p:nvSpPr>
+        <p:spPr>
+          <a:xfrm>
+            <a:off x="9144000" y="6601968"/>
+            <a:ext cx="2743200" cy="228600"/>
+          </a:xfrm>
+          <a:prstGeom prst="rect">
+            <a:avLst/>
+          </a:prstGeom>
+          <a:noFill/>
+        </p:spPr>
+        <p:txBody>
+          <a:bodyPr wrap="none">
+            <a:spAutoFit/>
+          </a:bodyPr>
+          <a:lstStyle/>
+          <a:p>
+            <a:pPr algn="r">
+              <a:defRPr sz="1000" b="0">
+                <a:solidFill>
+                  <a:srgbClr val="555555"/>
+                </a:solidFill>
+                <a:latin typeface="Arial"/>
+              </a:defRPr>
+            </a:pPr>
+            <a:r>
+              <a:t>Sequenz 1</a:t>
+            </a:r>
+          </a:p>
+        </p:txBody>
+      </p:sp>
+      <p:sp>
+        <p:nvSpPr>
+          <p:cNvPr id="7" name="TextBox 6"/>
+          <p:cNvSpPr txBox="1"/>
+          <p:nvPr/>
+        </p:nvSpPr>
+        <p:spPr>
+          <a:xfrm>
+            <a:off x="457200" y="640080"/>
+            <a:ext cx="11274552" cy="731520"/>
+          </a:xfrm>
+          <a:prstGeom prst="rect">
+            <a:avLst/>
+          </a:prstGeom>
+          <a:noFill/>
+        </p:spPr>
+        <p:txBody>
+          <a:bodyPr wrap="none">
+            <a:spAutoFit/>
+          </a:bodyPr>
+          <a:lstStyle/>
+          <a:p>
+            <a:pPr algn="l">
+              <a:defRPr sz="3200" b="1">
+                <a:solidFill>
+                  <a:srgbClr val="C41E3A"/>
+                </a:solidFill>
+                <a:latin typeface="Arial"/>
+              </a:defRPr>
+            </a:pPr>
+            <a:r>
+              <a:t>Minitest: Überblick</a:t>
+            </a:r>
+          </a:p>
+        </p:txBody>
+      </p:sp>
+      <p:sp>
+        <p:nvSpPr>
+          <p:cNvPr id="8" name="TextBox 7"/>
+          <p:cNvSpPr txBox="1"/>
+          <p:nvPr/>
+        </p:nvSpPr>
+        <p:spPr>
+          <a:xfrm>
+            <a:off x="640080" y="1463040"/>
+            <a:ext cx="10972800" cy="548640"/>
+          </a:xfrm>
+          <a:prstGeom prst="rect">
+            <a:avLst/>
+          </a:prstGeom>
+          <a:noFill/>
+        </p:spPr>
+        <p:txBody>
+          <a:bodyPr wrap="none">
+            <a:spAutoFit/>
+          </a:bodyPr>
+          <a:lstStyle/>
+          <a:p>
+            <a:pPr algn="l">
+              <a:defRPr sz="2000" b="0">
+                <a:solidFill>
+                  <a:srgbClr val="222222"/>
+                </a:solidFill>
+                <a:latin typeface="Arial"/>
+              </a:defRPr>
+            </a:pPr>
+            <a:r>
+              <a:t>Teil 1: Begrüßung &amp; Verabschiedung (8 P)</a:t>
+            </a:r>
+          </a:p>
+        </p:txBody>
+      </p:sp>
+      <p:sp>
+        <p:nvSpPr>
+          <p:cNvPr id="9" name="TextBox 8"/>
+          <p:cNvSpPr txBox="1"/>
+          <p:nvPr/>
+        </p:nvSpPr>
+        <p:spPr>
+          <a:xfrm>
+            <a:off x="640080" y="2194560"/>
+            <a:ext cx="10972800" cy="548640"/>
+          </a:xfrm>
+          <a:prstGeom prst="rect">
+            <a:avLst/>
+          </a:prstGeom>
+          <a:noFill/>
+        </p:spPr>
+        <p:txBody>
+          <a:bodyPr wrap="none">
+            <a:spAutoFit/>
+          </a:bodyPr>
+          <a:lstStyle/>
+          <a:p>
+            <a:pPr algn="l">
+              <a:defRPr sz="2000" b="0">
+                <a:solidFill>
+                  <a:srgbClr val="222222"/>
+                </a:solidFill>
+                <a:latin typeface="Arial"/>
+              </a:defRPr>
+            </a:pPr>
+            <a:r>
+              <a:t>Teil 2: ser-Konjugation (6 P)</a:t>
+            </a:r>
+          </a:p>
+        </p:txBody>
+      </p:sp>
+      <p:sp>
+        <p:nvSpPr>
+          <p:cNvPr id="10" name="TextBox 9"/>
+          <p:cNvSpPr txBox="1"/>
+          <p:nvPr/>
+        </p:nvSpPr>
+        <p:spPr>
+          <a:xfrm>
+            <a:off x="640080" y="2926080"/>
+            <a:ext cx="10972800" cy="548640"/>
+          </a:xfrm>
+          <a:prstGeom prst="rect">
+            <a:avLst/>
+          </a:prstGeom>
+          <a:noFill/>
+        </p:spPr>
+        <p:txBody>
+          <a:bodyPr wrap="none">
+            <a:spAutoFit/>
+          </a:bodyPr>
+          <a:lstStyle/>
+          <a:p>
+            <a:pPr algn="l">
+              <a:defRPr sz="2000" b="0">
+                <a:solidFill>
+                  <a:srgbClr val="222222"/>
+                </a:solidFill>
+                <a:latin typeface="Arial"/>
+              </a:defRPr>
+            </a:pPr>
+            <a:r>
+              <a:t>Teil 3: Artikel ergänzen (6 P)</a:t>
+            </a:r>
+          </a:p>
+        </p:txBody>
+      </p:sp>
+      <p:sp>
+        <p:nvSpPr>
+          <p:cNvPr id="11" name="TextBox 10"/>
+          <p:cNvSpPr txBox="1"/>
+          <p:nvPr/>
+        </p:nvSpPr>
+        <p:spPr>
+          <a:xfrm>
+            <a:off x="640080" y="3657600"/>
+            <a:ext cx="10972800" cy="548640"/>
+          </a:xfrm>
+          <a:prstGeom prst="rect">
+            <a:avLst/>
+          </a:prstGeom>
+          <a:noFill/>
+        </p:spPr>
+        <p:txBody>
+          <a:bodyPr wrap="none">
+            <a:spAutoFit/>
+          </a:bodyPr>
+          <a:lstStyle/>
+          <a:p>
+            <a:pPr algn="l">
+              <a:defRPr sz="2000" b="0">
+                <a:solidFill>
+                  <a:srgbClr val="222222"/>
+                </a:solidFill>
+                <a:latin typeface="Arial"/>
+              </a:defRPr>
+            </a:pPr>
+            <a:r>
+              <a:t>Teil 4: Sich vorstellen (5 P)</a:t>
+            </a:r>
+          </a:p>
+        </p:txBody>
+      </p:sp>
+    </p:spTree>
+  </p:cSld>
+  <p:clrMapOvr>
+    <a:masterClrMapping/>
+  </p:clrMapOvr>
+</p:sld>
+</file>
+
+<file path=ppt/slides/slide7.xml><?xml version="1.0" encoding="utf-8"?>
+<p:sld xmlns:a="http://schemas.openxmlformats.org/drawingml/2006/main" xmlns:p="http://schemas.openxmlformats.org/presentationml/2006/main" xmlns:r="http://schemas.openxmlformats.org/officeDocument/2006/relationships">
+  <p:cSld>
+    <p:spTree>
+      <p:nvGrpSpPr>
+        <p:cNvPr id="1" name=""/>
+        <p:cNvGrpSpPr/>
+        <p:nvPr/>
+      </p:nvGrpSpPr>
+      <p:grpSpPr/>
+      <p:sp>
+        <p:nvSpPr>
+          <p:cNvPr id="2" name="Rectangle 1"/>
+          <p:cNvSpPr/>
+          <p:nvPr/>
+        </p:nvSpPr>
+        <p:spPr>
+          <a:xfrm>
+            <a:off x="0" y="0"/>
+            <a:ext cx="12191695" cy="457200"/>
+          </a:xfrm>
+          <a:prstGeom prst="rect">
+            <a:avLst/>
+          </a:prstGeom>
+          <a:solidFill>
+            <a:srgbClr val="C41E3A"/>
+          </a:solidFill>
+          <a:ln>
+            <a:noFill/>
+          </a:ln>
+        </p:spPr>
+        <p:style>
+          <a:lnRef idx="1">
+            <a:schemeClr val="accent1"/>
+          </a:lnRef>
+          <a:fillRef idx="3">
+            <a:schemeClr val="accent1"/>
+          </a:fillRef>
+          <a:effectRef idx="2">
+            <a:schemeClr val="accent1"/>
+          </a:effectRef>
+          <a:fontRef idx="minor">
+            <a:schemeClr val="lt1"/>
+          </a:fontRef>
+        </p:style>
+        <p:txBody>
+          <a:bodyPr rtlCol="0" anchor="ctr"/>
+          <a:lstStyle/>
+          <a:p>
+            <a:pPr algn="ctr"/>
+          </a:p>
+        </p:txBody>
+      </p:sp>
+      <p:sp>
+        <p:nvSpPr>
+          <p:cNvPr id="3" name="TextBox 2"/>
+          <p:cNvSpPr txBox="1"/>
+          <p:nvPr/>
+        </p:nvSpPr>
+        <p:spPr>
+          <a:xfrm>
+            <a:off x="274320" y="91440"/>
+            <a:ext cx="3657600" cy="274320"/>
+          </a:xfrm>
+          <a:prstGeom prst="rect">
+            <a:avLst/>
+          </a:prstGeom>
+          <a:noFill/>
+        </p:spPr>
+        <p:txBody>
+          <a:bodyPr wrap="none">
+            <a:spAutoFit/>
+          </a:bodyPr>
+          <a:lstStyle/>
+          <a:p>
+            <a:pPr algn="l">
+              <a:defRPr sz="1400" b="1">
+                <a:solidFill>
+                  <a:srgbClr val="FFFFFF"/>
+                </a:solidFill>
+                <a:latin typeface="Arial"/>
+              </a:defRPr>
+            </a:pPr>
+            <a:r>
+              <a:t>Spanisch Klasse 7 · LP-01d</a:t>
+            </a:r>
+          </a:p>
+        </p:txBody>
+      </p:sp>
+      <p:sp>
+        <p:nvSpPr>
+          <p:cNvPr id="4" name="Rectangle 3"/>
+          <p:cNvSpPr/>
+          <p:nvPr/>
+        </p:nvSpPr>
+        <p:spPr>
+          <a:xfrm>
+            <a:off x="0" y="6583680"/>
+            <a:ext cx="12191695" cy="274320"/>
+          </a:xfrm>
+          <a:prstGeom prst="rect">
+            <a:avLst/>
+          </a:prstGeom>
+          <a:solidFill>
+            <a:srgbClr val="F5F5F5"/>
+          </a:solidFill>
+          <a:ln>
+            <a:noFill/>
+          </a:ln>
+        </p:spPr>
+        <p:style>
+          <a:lnRef idx="1">
+            <a:schemeClr val="accent1"/>
+          </a:lnRef>
+          <a:fillRef idx="3">
+            <a:schemeClr val="accent1"/>
+          </a:fillRef>
+          <a:effectRef idx="2">
+            <a:schemeClr val="accent1"/>
+          </a:effectRef>
+          <a:fontRef idx="minor">
+            <a:schemeClr val="lt1"/>
+          </a:fontRef>
+        </p:style>
+        <p:txBody>
+          <a:bodyPr rtlCol="0" anchor="ctr"/>
+          <a:lstStyle/>
+          <a:p>
+            <a:pPr algn="ctr"/>
+          </a:p>
+        </p:txBody>
+      </p:sp>
+      <p:sp>
+        <p:nvSpPr>
+          <p:cNvPr id="5" name="TextBox 4"/>
+          <p:cNvSpPr txBox="1"/>
+          <p:nvPr/>
+        </p:nvSpPr>
+        <p:spPr>
+          <a:xfrm>
+            <a:off x="274320" y="6601968"/>
+            <a:ext cx="4572000" cy="228600"/>
+          </a:xfrm>
+          <a:prstGeom prst="rect">
+            <a:avLst/>
+          </a:prstGeom>
+          <a:noFill/>
+        </p:spPr>
+        <p:txBody>
+          <a:bodyPr wrap="none">
+            <a:spAutoFit/>
+          </a:bodyPr>
+          <a:lstStyle/>
+          <a:p>
+            <a:pPr algn="l">
+              <a:defRPr sz="1000" b="0">
+                <a:solidFill>
+                  <a:srgbClr val="555555"/>
+                </a:solidFill>
+                <a:latin typeface="Arial"/>
+              </a:defRPr>
+            </a:pPr>
+            <a:r>
+              <a:t>¿Qué tal?</a:t>
+            </a:r>
+          </a:p>
+        </p:txBody>
+      </p:sp>
+      <p:sp>
+        <p:nvSpPr>
+          <p:cNvPr id="6" name="TextBox 5"/>
+          <p:cNvSpPr txBox="1"/>
+          <p:nvPr/>
+        </p:nvSpPr>
+        <p:spPr>
+          <a:xfrm>
+            <a:off x="9144000" y="6601968"/>
+            <a:ext cx="2743200" cy="228600"/>
+          </a:xfrm>
+          <a:prstGeom prst="rect">
+            <a:avLst/>
+          </a:prstGeom>
+          <a:noFill/>
+        </p:spPr>
+        <p:txBody>
+          <a:bodyPr wrap="none">
+            <a:spAutoFit/>
+          </a:bodyPr>
+          <a:lstStyle/>
+          <a:p>
+            <a:pPr algn="r">
+              <a:defRPr sz="1000" b="0">
+                <a:solidFill>
+                  <a:srgbClr val="555555"/>
+                </a:solidFill>
+                <a:latin typeface="Arial"/>
+              </a:defRPr>
+            </a:pPr>
+            <a:r>
+              <a:t>Sequenz 1</a:t>
+            </a:r>
+          </a:p>
+        </p:txBody>
+      </p:sp>
+      <p:sp>
+        <p:nvSpPr>
+          <p:cNvPr id="7" name="Rectangle 6"/>
+          <p:cNvSpPr/>
+          <p:nvPr/>
+        </p:nvSpPr>
+        <p:spPr>
+          <a:xfrm>
+            <a:off x="457200" y="640080"/>
+            <a:ext cx="1828800" cy="457200"/>
+          </a:xfrm>
+          <a:prstGeom prst="rect">
+            <a:avLst/>
+          </a:prstGeom>
+          <a:solidFill>
+            <a:srgbClr val="C41E3A"/>
+          </a:solidFill>
+          <a:ln>
+            <a:noFill/>
+          </a:ln>
+        </p:spPr>
+        <p:style>
+          <a:lnRef idx="1">
+            <a:schemeClr val="accent1"/>
+          </a:lnRef>
+          <a:fillRef idx="3">
+            <a:schemeClr val="accent1"/>
+          </a:fillRef>
+          <a:effectRef idx="2">
+            <a:schemeClr val="accent1"/>
+          </a:effectRef>
+          <a:fontRef idx="minor">
+            <a:schemeClr val="lt1"/>
+          </a:fontRef>
+        </p:style>
+        <p:txBody>
+          <a:bodyPr rtlCol="0" anchor="ctr"/>
+          <a:lstStyle/>
+          <a:p>
+            <a:pPr algn="ctr"/>
+          </a:p>
+        </p:txBody>
+      </p:sp>
+      <p:sp>
+        <p:nvSpPr>
           <p:cNvPr id="8" name="TextBox 7"/>
           <p:cNvSpPr txBox="1"/>
           <p:nvPr/>
@@ -4420,7 +6826,7 @@
               </a:defRPr>
             </a:pPr>
             <a:r>
-              <a:t>HAUSAUFGABE</a:t>
+              <a:t>ÜBUNG</a:t>
             </a:r>
           </a:p>
         </p:txBody>
@@ -4456,7 +6862,7 @@
               </a:defRPr>
             </a:pPr>
             <a:r>
-              <a:t>📚 Para casa</a:t>
+              <a:t>✏️ Probe: Begrüßung</a:t>
             </a:r>
           </a:p>
         </p:txBody>
@@ -4469,30 +6875,30 @@
         </p:nvSpPr>
         <p:spPr>
           <a:xfrm>
-            <a:off x="640080" y="2103120"/>
-            <a:ext cx="457200" cy="457200"/>
-          </a:xfrm>
-          <a:prstGeom prst="rect">
-            <a:avLst/>
-          </a:prstGeom>
-          <a:noFill/>
-        </p:spPr>
-        <p:txBody>
-          <a:bodyPr wrap="none">
-            <a:spAutoFit/>
-          </a:bodyPr>
-          <a:lstStyle/>
-          <a:p>
-            <a:pPr algn="l">
-              <a:defRPr sz="2400" b="1">
-                <a:solidFill>
-                  <a:srgbClr val="2A7A4B"/>
-                </a:solidFill>
-                <a:latin typeface="Arial"/>
-              </a:defRPr>
-            </a:pPr>
-            <a:r>
-              <a:t>✓</a:t>
+            <a:off x="640080" y="2011680"/>
+            <a:ext cx="5029200" cy="548640"/>
+          </a:xfrm>
+          <a:prstGeom prst="rect">
+            <a:avLst/>
+          </a:prstGeom>
+          <a:noFill/>
+        </p:spPr>
+        <p:txBody>
+          <a:bodyPr wrap="none">
+            <a:spAutoFit/>
+          </a:bodyPr>
+          <a:lstStyle/>
+          <a:p>
+            <a:pPr algn="l">
+              <a:defRPr sz="2200" b="1">
+                <a:solidFill>
+                  <a:srgbClr val="C41E3A"/>
+                </a:solidFill>
+                <a:latin typeface="Arial"/>
+              </a:defRPr>
+            </a:pPr>
+            <a:r>
+              <a:t>Guten Morgen =</a:t>
             </a:r>
           </a:p>
         </p:txBody>
@@ -4505,30 +6911,30 @@
         </p:nvSpPr>
         <p:spPr>
           <a:xfrm>
-            <a:off x="1188720" y="2103120"/>
-            <a:ext cx="10058400" cy="457200"/>
-          </a:xfrm>
-          <a:prstGeom prst="rect">
-            <a:avLst/>
-          </a:prstGeom>
-          <a:noFill/>
-        </p:spPr>
-        <p:txBody>
-          <a:bodyPr wrap="none">
-            <a:spAutoFit/>
-          </a:bodyPr>
-          <a:lstStyle/>
-          <a:p>
-            <a:pPr algn="l">
-              <a:defRPr sz="2000" b="0">
-                <a:solidFill>
-                  <a:srgbClr val="222222"/>
-                </a:solidFill>
-                <a:latin typeface="Arial"/>
-              </a:defRPr>
-            </a:pPr>
-            <a:r>
-              <a:t>Alle Vokabeln</a:t>
+            <a:off x="5943600" y="2011680"/>
+            <a:ext cx="5029200" cy="548640"/>
+          </a:xfrm>
+          <a:prstGeom prst="rect">
+            <a:avLst/>
+          </a:prstGeom>
+          <a:noFill/>
+        </p:spPr>
+        <p:txBody>
+          <a:bodyPr wrap="none">
+            <a:spAutoFit/>
+          </a:bodyPr>
+          <a:lstStyle/>
+          <a:p>
+            <a:pPr algn="l">
+              <a:defRPr sz="2200" b="0">
+                <a:solidFill>
+                  <a:srgbClr val="888888"/>
+                </a:solidFill>
+                <a:latin typeface="Arial"/>
+              </a:defRPr>
+            </a:pPr>
+            <a:r>
+              <a:t>___</a:t>
             </a:r>
           </a:p>
         </p:txBody>
@@ -4541,30 +6947,30 @@
         </p:nvSpPr>
         <p:spPr>
           <a:xfrm>
-            <a:off x="640080" y="2926079"/>
-            <a:ext cx="457200" cy="457200"/>
-          </a:xfrm>
-          <a:prstGeom prst="rect">
-            <a:avLst/>
-          </a:prstGeom>
-          <a:noFill/>
-        </p:spPr>
-        <p:txBody>
-          <a:bodyPr wrap="none">
-            <a:spAutoFit/>
-          </a:bodyPr>
-          <a:lstStyle/>
-          <a:p>
-            <a:pPr algn="l">
-              <a:defRPr sz="2400" b="1">
-                <a:solidFill>
-                  <a:srgbClr val="2A7A4B"/>
-                </a:solidFill>
-                <a:latin typeface="Arial"/>
-              </a:defRPr>
-            </a:pPr>
-            <a:r>
-              <a:t>✓</a:t>
+            <a:off x="640080" y="2926080"/>
+            <a:ext cx="5029200" cy="548640"/>
+          </a:xfrm>
+          <a:prstGeom prst="rect">
+            <a:avLst/>
+          </a:prstGeom>
+          <a:noFill/>
+        </p:spPr>
+        <p:txBody>
+          <a:bodyPr wrap="none">
+            <a:spAutoFit/>
+          </a:bodyPr>
+          <a:lstStyle/>
+          <a:p>
+            <a:pPr algn="l">
+              <a:defRPr sz="2200" b="1">
+                <a:solidFill>
+                  <a:srgbClr val="C41E3A"/>
+                </a:solidFill>
+                <a:latin typeface="Arial"/>
+              </a:defRPr>
+            </a:pPr>
+            <a:r>
+              <a:t>Tschüss =</a:t>
             </a:r>
           </a:p>
         </p:txBody>
@@ -4577,48 +6983,384 @@
         </p:nvSpPr>
         <p:spPr>
           <a:xfrm>
-            <a:off x="1188720" y="2926079"/>
-            <a:ext cx="10058400" cy="457200"/>
-          </a:xfrm>
-          <a:prstGeom prst="rect">
-            <a:avLst/>
-          </a:prstGeom>
-          <a:noFill/>
-        </p:spPr>
-        <p:txBody>
-          <a:bodyPr wrap="none">
-            <a:spAutoFit/>
-          </a:bodyPr>
-          <a:lstStyle/>
-          <a:p>
-            <a:pPr algn="l">
-              <a:defRPr sz="2000" b="0">
-                <a:solidFill>
-                  <a:srgbClr val="222222"/>
-                </a:solidFill>
-                <a:latin typeface="Arial"/>
-              </a:defRPr>
-            </a:pPr>
-            <a:r>
-              <a:t>ser üben</a:t>
-            </a:r>
-          </a:p>
-        </p:txBody>
-      </p:sp>
-      <p:sp>
-        <p:nvSpPr>
-          <p:cNvPr id="14" name="TextBox 13"/>
-          <p:cNvSpPr txBox="1"/>
-          <p:nvPr/>
-        </p:nvSpPr>
-        <p:spPr>
-          <a:xfrm>
-            <a:off x="457200" y="5760720"/>
+            <a:off x="5943600" y="2926080"/>
+            <a:ext cx="5029200" cy="548640"/>
+          </a:xfrm>
+          <a:prstGeom prst="rect">
+            <a:avLst/>
+          </a:prstGeom>
+          <a:noFill/>
+        </p:spPr>
+        <p:txBody>
+          <a:bodyPr wrap="none">
+            <a:spAutoFit/>
+          </a:bodyPr>
+          <a:lstStyle/>
+          <a:p>
+            <a:pPr algn="l">
+              <a:defRPr sz="2200" b="0">
+                <a:solidFill>
+                  <a:srgbClr val="888888"/>
+                </a:solidFill>
+                <a:latin typeface="Arial"/>
+              </a:defRPr>
+            </a:pPr>
+            <a:r>
+              <a:t>___</a:t>
+            </a:r>
+          </a:p>
+        </p:txBody>
+      </p:sp>
+      <p:sp>
+        <p:nvSpPr>
+          <p:cNvPr id="14" name="Rectangle 13"/>
+          <p:cNvSpPr/>
+          <p:nvPr/>
+        </p:nvSpPr>
+        <p:spPr>
+          <a:xfrm>
+            <a:off x="457200" y="5943600"/>
             <a:ext cx="11274552" cy="548640"/>
           </a:xfrm>
           <a:prstGeom prst="rect">
             <a:avLst/>
           </a:prstGeom>
+          <a:solidFill>
+            <a:srgbClr val="FDF2F4"/>
+          </a:solidFill>
+          <a:ln>
+            <a:solidFill>
+              <a:srgbClr val="C41E3A"/>
+            </a:solidFill>
+          </a:ln>
+        </p:spPr>
+        <p:style>
+          <a:lnRef idx="1">
+            <a:schemeClr val="accent1"/>
+          </a:lnRef>
+          <a:fillRef idx="3">
+            <a:schemeClr val="accent1"/>
+          </a:fillRef>
+          <a:effectRef idx="2">
+            <a:schemeClr val="accent1"/>
+          </a:effectRef>
+          <a:fontRef idx="minor">
+            <a:schemeClr val="lt1"/>
+          </a:fontRef>
+        </p:style>
+        <p:txBody>
+          <a:bodyPr rtlCol="0" anchor="ctr"/>
+          <a:lstStyle/>
+          <a:p>
+            <a:pPr algn="ctr"/>
+          </a:p>
+        </p:txBody>
+      </p:sp>
+      <p:sp>
+        <p:nvSpPr>
+          <p:cNvPr id="15" name="TextBox 14"/>
+          <p:cNvSpPr txBox="1"/>
+          <p:nvPr/>
+        </p:nvSpPr>
+        <p:spPr>
+          <a:xfrm>
+            <a:off x="640080" y="6053328"/>
+            <a:ext cx="10972800" cy="365760"/>
+          </a:xfrm>
+          <a:prstGeom prst="rect">
+            <a:avLst/>
+          </a:prstGeom>
+          <a:noFill/>
+        </p:spPr>
+        <p:txBody>
+          <a:bodyPr wrap="none">
+            <a:spAutoFit/>
+          </a:bodyPr>
+          <a:lstStyle/>
+          <a:p>
+            <a:pPr algn="l">
+              <a:defRPr sz="1400" b="1">
+                <a:solidFill>
+                  <a:srgbClr val="C41E3A"/>
+                </a:solidFill>
+                <a:latin typeface="Arial"/>
+              </a:defRPr>
+            </a:pPr>
+            <a:r>
+              <a:t>📝 MT-01d</a:t>
+            </a:r>
+          </a:p>
+        </p:txBody>
+      </p:sp>
+    </p:spTree>
+  </p:cSld>
+  <p:clrMapOvr>
+    <a:masterClrMapping/>
+  </p:clrMapOvr>
+</p:sld>
+</file>
+
+<file path=ppt/slides/slide8.xml><?xml version="1.0" encoding="utf-8"?>
+<p:sld xmlns:a="http://schemas.openxmlformats.org/drawingml/2006/main" xmlns:p="http://schemas.openxmlformats.org/presentationml/2006/main" xmlns:r="http://schemas.openxmlformats.org/officeDocument/2006/relationships">
+  <p:cSld>
+    <p:spTree>
+      <p:nvGrpSpPr>
+        <p:cNvPr id="1" name=""/>
+        <p:cNvGrpSpPr/>
+        <p:nvPr/>
+      </p:nvGrpSpPr>
+      <p:grpSpPr/>
+      <p:sp>
+        <p:nvSpPr>
+          <p:cNvPr id="2" name="Rectangle 1"/>
+          <p:cNvSpPr/>
+          <p:nvPr/>
+        </p:nvSpPr>
+        <p:spPr>
+          <a:xfrm>
+            <a:off x="0" y="0"/>
+            <a:ext cx="12191695" cy="457200"/>
+          </a:xfrm>
+          <a:prstGeom prst="rect">
+            <a:avLst/>
+          </a:prstGeom>
+          <a:solidFill>
+            <a:srgbClr val="C41E3A"/>
+          </a:solidFill>
+          <a:ln>
+            <a:noFill/>
+          </a:ln>
+        </p:spPr>
+        <p:style>
+          <a:lnRef idx="1">
+            <a:schemeClr val="accent1"/>
+          </a:lnRef>
+          <a:fillRef idx="3">
+            <a:schemeClr val="accent1"/>
+          </a:fillRef>
+          <a:effectRef idx="2">
+            <a:schemeClr val="accent1"/>
+          </a:effectRef>
+          <a:fontRef idx="minor">
+            <a:schemeClr val="lt1"/>
+          </a:fontRef>
+        </p:style>
+        <p:txBody>
+          <a:bodyPr rtlCol="0" anchor="ctr"/>
+          <a:lstStyle/>
+          <a:p>
+            <a:pPr algn="ctr"/>
+          </a:p>
+        </p:txBody>
+      </p:sp>
+      <p:sp>
+        <p:nvSpPr>
+          <p:cNvPr id="3" name="TextBox 2"/>
+          <p:cNvSpPr txBox="1"/>
+          <p:nvPr/>
+        </p:nvSpPr>
+        <p:spPr>
+          <a:xfrm>
+            <a:off x="274320" y="91440"/>
+            <a:ext cx="3657600" cy="274320"/>
+          </a:xfrm>
+          <a:prstGeom prst="rect">
+            <a:avLst/>
+          </a:prstGeom>
+          <a:noFill/>
+        </p:spPr>
+        <p:txBody>
+          <a:bodyPr wrap="none">
+            <a:spAutoFit/>
+          </a:bodyPr>
+          <a:lstStyle/>
+          <a:p>
+            <a:pPr algn="l">
+              <a:defRPr sz="1400" b="1">
+                <a:solidFill>
+                  <a:srgbClr val="FFFFFF"/>
+                </a:solidFill>
+                <a:latin typeface="Arial"/>
+              </a:defRPr>
+            </a:pPr>
+            <a:r>
+              <a:t>Spanisch Klasse 7 · LP-01d</a:t>
+            </a:r>
+          </a:p>
+        </p:txBody>
+      </p:sp>
+      <p:sp>
+        <p:nvSpPr>
+          <p:cNvPr id="4" name="Rectangle 3"/>
+          <p:cNvSpPr/>
+          <p:nvPr/>
+        </p:nvSpPr>
+        <p:spPr>
+          <a:xfrm>
+            <a:off x="0" y="6583680"/>
+            <a:ext cx="12191695" cy="274320"/>
+          </a:xfrm>
+          <a:prstGeom prst="rect">
+            <a:avLst/>
+          </a:prstGeom>
+          <a:solidFill>
+            <a:srgbClr val="F5F5F5"/>
+          </a:solidFill>
+          <a:ln>
+            <a:noFill/>
+          </a:ln>
+        </p:spPr>
+        <p:style>
+          <a:lnRef idx="1">
+            <a:schemeClr val="accent1"/>
+          </a:lnRef>
+          <a:fillRef idx="3">
+            <a:schemeClr val="accent1"/>
+          </a:fillRef>
+          <a:effectRef idx="2">
+            <a:schemeClr val="accent1"/>
+          </a:effectRef>
+          <a:fontRef idx="minor">
+            <a:schemeClr val="lt1"/>
+          </a:fontRef>
+        </p:style>
+        <p:txBody>
+          <a:bodyPr rtlCol="0" anchor="ctr"/>
+          <a:lstStyle/>
+          <a:p>
+            <a:pPr algn="ctr"/>
+          </a:p>
+        </p:txBody>
+      </p:sp>
+      <p:sp>
+        <p:nvSpPr>
+          <p:cNvPr id="5" name="TextBox 4"/>
+          <p:cNvSpPr txBox="1"/>
+          <p:nvPr/>
+        </p:nvSpPr>
+        <p:spPr>
+          <a:xfrm>
+            <a:off x="274320" y="6601968"/>
+            <a:ext cx="4572000" cy="228600"/>
+          </a:xfrm>
+          <a:prstGeom prst="rect">
+            <a:avLst/>
+          </a:prstGeom>
+          <a:noFill/>
+        </p:spPr>
+        <p:txBody>
+          <a:bodyPr wrap="none">
+            <a:spAutoFit/>
+          </a:bodyPr>
+          <a:lstStyle/>
+          <a:p>
+            <a:pPr algn="l">
+              <a:defRPr sz="1000" b="0">
+                <a:solidFill>
+                  <a:srgbClr val="555555"/>
+                </a:solidFill>
+                <a:latin typeface="Arial"/>
+              </a:defRPr>
+            </a:pPr>
+            <a:r>
+              <a:t>¿Qué tal?</a:t>
+            </a:r>
+          </a:p>
+        </p:txBody>
+      </p:sp>
+      <p:sp>
+        <p:nvSpPr>
+          <p:cNvPr id="6" name="TextBox 5"/>
+          <p:cNvSpPr txBox="1"/>
+          <p:nvPr/>
+        </p:nvSpPr>
+        <p:spPr>
+          <a:xfrm>
+            <a:off x="9144000" y="6601968"/>
+            <a:ext cx="2743200" cy="228600"/>
+          </a:xfrm>
+          <a:prstGeom prst="rect">
+            <a:avLst/>
+          </a:prstGeom>
+          <a:noFill/>
+        </p:spPr>
+        <p:txBody>
+          <a:bodyPr wrap="none">
+            <a:spAutoFit/>
+          </a:bodyPr>
+          <a:lstStyle/>
+          <a:p>
+            <a:pPr algn="r">
+              <a:defRPr sz="1000" b="0">
+                <a:solidFill>
+                  <a:srgbClr val="555555"/>
+                </a:solidFill>
+                <a:latin typeface="Arial"/>
+              </a:defRPr>
+            </a:pPr>
+            <a:r>
+              <a:t>Sequenz 1</a:t>
+            </a:r>
+          </a:p>
+        </p:txBody>
+      </p:sp>
+      <p:sp>
+        <p:nvSpPr>
+          <p:cNvPr id="7" name="Rectangle 6"/>
+          <p:cNvSpPr/>
+          <p:nvPr/>
+        </p:nvSpPr>
+        <p:spPr>
+          <a:xfrm>
+            <a:off x="457200" y="640080"/>
+            <a:ext cx="1828800" cy="457200"/>
+          </a:xfrm>
+          <a:prstGeom prst="rect">
+            <a:avLst/>
+          </a:prstGeom>
+          <a:solidFill>
+            <a:srgbClr val="C41E3A"/>
+          </a:solidFill>
+          <a:ln>
+            <a:noFill/>
+          </a:ln>
+        </p:spPr>
+        <p:style>
+          <a:lnRef idx="1">
+            <a:schemeClr val="accent1"/>
+          </a:lnRef>
+          <a:fillRef idx="3">
+            <a:schemeClr val="accent1"/>
+          </a:fillRef>
+          <a:effectRef idx="2">
+            <a:schemeClr val="accent1"/>
+          </a:effectRef>
+          <a:fontRef idx="minor">
+            <a:schemeClr val="lt1"/>
+          </a:fontRef>
+        </p:style>
+        <p:txBody>
+          <a:bodyPr rtlCol="0" anchor="ctr"/>
+          <a:lstStyle/>
+          <a:p>
+            <a:pPr algn="ctr"/>
+          </a:p>
+        </p:txBody>
+      </p:sp>
+      <p:sp>
+        <p:nvSpPr>
+          <p:cNvPr id="8" name="TextBox 7"/>
+          <p:cNvSpPr txBox="1"/>
+          <p:nvPr/>
+        </p:nvSpPr>
+        <p:spPr>
+          <a:xfrm>
+            <a:off x="548640" y="713231"/>
+            <a:ext cx="1645920" cy="320040"/>
+          </a:xfrm>
+          <a:prstGeom prst="rect">
+            <a:avLst/>
+          </a:prstGeom>
           <a:noFill/>
         </p:spPr>
         <p:txBody>
@@ -4628,6 +7370,42 @@
           <a:lstStyle/>
           <a:p>
             <a:pPr algn="ctr">
+              <a:defRPr sz="1400" b="1">
+                <a:solidFill>
+                  <a:srgbClr val="FFFFFF"/>
+                </a:solidFill>
+                <a:latin typeface="Arial"/>
+              </a:defRPr>
+            </a:pPr>
+            <a:r>
+              <a:t>ÜBUNG</a:t>
+            </a:r>
+          </a:p>
+        </p:txBody>
+      </p:sp>
+      <p:sp>
+        <p:nvSpPr>
+          <p:cNvPr id="9" name="TextBox 8"/>
+          <p:cNvSpPr txBox="1"/>
+          <p:nvPr/>
+        </p:nvSpPr>
+        <p:spPr>
+          <a:xfrm>
+            <a:off x="457200" y="1280160"/>
+            <a:ext cx="11274552" cy="731520"/>
+          </a:xfrm>
+          <a:prstGeom prst="rect">
+            <a:avLst/>
+          </a:prstGeom>
+          <a:noFill/>
+        </p:spPr>
+        <p:txBody>
+          <a:bodyPr wrap="none">
+            <a:spAutoFit/>
+          </a:bodyPr>
+          <a:lstStyle/>
+          <a:p>
+            <a:pPr algn="l">
               <a:defRPr sz="3200" b="1">
                 <a:solidFill>
                   <a:srgbClr val="C41E3A"/>
@@ -4636,7 +7414,784 @@
               </a:defRPr>
             </a:pPr>
             <a:r>
-              <a:t>¡Buena suerte!</a:t>
+              <a:t>✏️ Probe: ser</a:t>
+            </a:r>
+          </a:p>
+        </p:txBody>
+      </p:sp>
+      <p:sp>
+        <p:nvSpPr>
+          <p:cNvPr id="10" name="TextBox 9"/>
+          <p:cNvSpPr txBox="1"/>
+          <p:nvPr/>
+        </p:nvSpPr>
+        <p:spPr>
+          <a:xfrm>
+            <a:off x="640080" y="2011680"/>
+            <a:ext cx="5029200" cy="548640"/>
+          </a:xfrm>
+          <a:prstGeom prst="rect">
+            <a:avLst/>
+          </a:prstGeom>
+          <a:noFill/>
+        </p:spPr>
+        <p:txBody>
+          <a:bodyPr wrap="none">
+            <a:spAutoFit/>
+          </a:bodyPr>
+          <a:lstStyle/>
+          <a:p>
+            <a:pPr algn="l">
+              <a:defRPr sz="2200" b="1">
+                <a:solidFill>
+                  <a:srgbClr val="C41E3A"/>
+                </a:solidFill>
+                <a:latin typeface="Arial"/>
+              </a:defRPr>
+            </a:pPr>
+            <a:r>
+              <a:t>Yo ___ de Alemania.</a:t>
+            </a:r>
+          </a:p>
+        </p:txBody>
+      </p:sp>
+      <p:sp>
+        <p:nvSpPr>
+          <p:cNvPr id="11" name="TextBox 10"/>
+          <p:cNvSpPr txBox="1"/>
+          <p:nvPr/>
+        </p:nvSpPr>
+        <p:spPr>
+          <a:xfrm>
+            <a:off x="5943600" y="2011680"/>
+            <a:ext cx="5029200" cy="548640"/>
+          </a:xfrm>
+          <a:prstGeom prst="rect">
+            <a:avLst/>
+          </a:prstGeom>
+          <a:noFill/>
+        </p:spPr>
+        <p:txBody>
+          <a:bodyPr wrap="none">
+            <a:spAutoFit/>
+          </a:bodyPr>
+          <a:lstStyle/>
+          <a:p>
+            <a:pPr algn="l">
+              <a:defRPr sz="2200" b="0">
+                <a:solidFill>
+                  <a:srgbClr val="888888"/>
+                </a:solidFill>
+                <a:latin typeface="Arial"/>
+              </a:defRPr>
+            </a:pPr>
+            <a:r>
+              <a:t>___</a:t>
+            </a:r>
+          </a:p>
+        </p:txBody>
+      </p:sp>
+      <p:sp>
+        <p:nvSpPr>
+          <p:cNvPr id="12" name="TextBox 11"/>
+          <p:cNvSpPr txBox="1"/>
+          <p:nvPr/>
+        </p:nvSpPr>
+        <p:spPr>
+          <a:xfrm>
+            <a:off x="640080" y="2926080"/>
+            <a:ext cx="5029200" cy="548640"/>
+          </a:xfrm>
+          <a:prstGeom prst="rect">
+            <a:avLst/>
+          </a:prstGeom>
+          <a:noFill/>
+        </p:spPr>
+        <p:txBody>
+          <a:bodyPr wrap="none">
+            <a:spAutoFit/>
+          </a:bodyPr>
+          <a:lstStyle/>
+          <a:p>
+            <a:pPr algn="l">
+              <a:defRPr sz="2200" b="1">
+                <a:solidFill>
+                  <a:srgbClr val="C41E3A"/>
+                </a:solidFill>
+                <a:latin typeface="Arial"/>
+              </a:defRPr>
+            </a:pPr>
+            <a:r>
+              <a:t>Ella ___ española.</a:t>
+            </a:r>
+          </a:p>
+        </p:txBody>
+      </p:sp>
+      <p:sp>
+        <p:nvSpPr>
+          <p:cNvPr id="13" name="TextBox 12"/>
+          <p:cNvSpPr txBox="1"/>
+          <p:nvPr/>
+        </p:nvSpPr>
+        <p:spPr>
+          <a:xfrm>
+            <a:off x="5943600" y="2926080"/>
+            <a:ext cx="5029200" cy="548640"/>
+          </a:xfrm>
+          <a:prstGeom prst="rect">
+            <a:avLst/>
+          </a:prstGeom>
+          <a:noFill/>
+        </p:spPr>
+        <p:txBody>
+          <a:bodyPr wrap="none">
+            <a:spAutoFit/>
+          </a:bodyPr>
+          <a:lstStyle/>
+          <a:p>
+            <a:pPr algn="l">
+              <a:defRPr sz="2200" b="0">
+                <a:solidFill>
+                  <a:srgbClr val="888888"/>
+                </a:solidFill>
+                <a:latin typeface="Arial"/>
+              </a:defRPr>
+            </a:pPr>
+            <a:r>
+              <a:t>___</a:t>
+            </a:r>
+          </a:p>
+        </p:txBody>
+      </p:sp>
+      <p:sp>
+        <p:nvSpPr>
+          <p:cNvPr id="14" name="Rectangle 13"/>
+          <p:cNvSpPr/>
+          <p:nvPr/>
+        </p:nvSpPr>
+        <p:spPr>
+          <a:xfrm>
+            <a:off x="457200" y="5943600"/>
+            <a:ext cx="11274552" cy="548640"/>
+          </a:xfrm>
+          <a:prstGeom prst="rect">
+            <a:avLst/>
+          </a:prstGeom>
+          <a:solidFill>
+            <a:srgbClr val="FDF2F4"/>
+          </a:solidFill>
+          <a:ln>
+            <a:solidFill>
+              <a:srgbClr val="C41E3A"/>
+            </a:solidFill>
+          </a:ln>
+        </p:spPr>
+        <p:style>
+          <a:lnRef idx="1">
+            <a:schemeClr val="accent1"/>
+          </a:lnRef>
+          <a:fillRef idx="3">
+            <a:schemeClr val="accent1"/>
+          </a:fillRef>
+          <a:effectRef idx="2">
+            <a:schemeClr val="accent1"/>
+          </a:effectRef>
+          <a:fontRef idx="minor">
+            <a:schemeClr val="lt1"/>
+          </a:fontRef>
+        </p:style>
+        <p:txBody>
+          <a:bodyPr rtlCol="0" anchor="ctr"/>
+          <a:lstStyle/>
+          <a:p>
+            <a:pPr algn="ctr"/>
+          </a:p>
+        </p:txBody>
+      </p:sp>
+      <p:sp>
+        <p:nvSpPr>
+          <p:cNvPr id="15" name="TextBox 14"/>
+          <p:cNvSpPr txBox="1"/>
+          <p:nvPr/>
+        </p:nvSpPr>
+        <p:spPr>
+          <a:xfrm>
+            <a:off x="640080" y="6053328"/>
+            <a:ext cx="10972800" cy="365760"/>
+          </a:xfrm>
+          <a:prstGeom prst="rect">
+            <a:avLst/>
+          </a:prstGeom>
+          <a:noFill/>
+        </p:spPr>
+        <p:txBody>
+          <a:bodyPr wrap="none">
+            <a:spAutoFit/>
+          </a:bodyPr>
+          <a:lstStyle/>
+          <a:p>
+            <a:pPr algn="l">
+              <a:defRPr sz="1400" b="1">
+                <a:solidFill>
+                  <a:srgbClr val="C41E3A"/>
+                </a:solidFill>
+                <a:latin typeface="Arial"/>
+              </a:defRPr>
+            </a:pPr>
+            <a:r>
+              <a:t>📝 MT-01d</a:t>
+            </a:r>
+          </a:p>
+        </p:txBody>
+      </p:sp>
+    </p:spTree>
+  </p:cSld>
+  <p:clrMapOvr>
+    <a:masterClrMapping/>
+  </p:clrMapOvr>
+</p:sld>
+</file>
+
+<file path=ppt/slides/slide9.xml><?xml version="1.0" encoding="utf-8"?>
+<p:sld xmlns:a="http://schemas.openxmlformats.org/drawingml/2006/main" xmlns:p="http://schemas.openxmlformats.org/presentationml/2006/main" xmlns:r="http://schemas.openxmlformats.org/officeDocument/2006/relationships">
+  <p:cSld>
+    <p:spTree>
+      <p:nvGrpSpPr>
+        <p:cNvPr id="1" name=""/>
+        <p:cNvGrpSpPr/>
+        <p:nvPr/>
+      </p:nvGrpSpPr>
+      <p:grpSpPr/>
+      <p:sp>
+        <p:nvSpPr>
+          <p:cNvPr id="2" name="Rectangle 1"/>
+          <p:cNvSpPr/>
+          <p:nvPr/>
+        </p:nvSpPr>
+        <p:spPr>
+          <a:xfrm>
+            <a:off x="0" y="0"/>
+            <a:ext cx="12191695" cy="457200"/>
+          </a:xfrm>
+          <a:prstGeom prst="rect">
+            <a:avLst/>
+          </a:prstGeom>
+          <a:solidFill>
+            <a:srgbClr val="C41E3A"/>
+          </a:solidFill>
+          <a:ln>
+            <a:noFill/>
+          </a:ln>
+        </p:spPr>
+        <p:style>
+          <a:lnRef idx="1">
+            <a:schemeClr val="accent1"/>
+          </a:lnRef>
+          <a:fillRef idx="3">
+            <a:schemeClr val="accent1"/>
+          </a:fillRef>
+          <a:effectRef idx="2">
+            <a:schemeClr val="accent1"/>
+          </a:effectRef>
+          <a:fontRef idx="minor">
+            <a:schemeClr val="lt1"/>
+          </a:fontRef>
+        </p:style>
+        <p:txBody>
+          <a:bodyPr rtlCol="0" anchor="ctr"/>
+          <a:lstStyle/>
+          <a:p>
+            <a:pPr algn="ctr"/>
+          </a:p>
+        </p:txBody>
+      </p:sp>
+      <p:sp>
+        <p:nvSpPr>
+          <p:cNvPr id="3" name="TextBox 2"/>
+          <p:cNvSpPr txBox="1"/>
+          <p:nvPr/>
+        </p:nvSpPr>
+        <p:spPr>
+          <a:xfrm>
+            <a:off x="274320" y="91440"/>
+            <a:ext cx="3657600" cy="274320"/>
+          </a:xfrm>
+          <a:prstGeom prst="rect">
+            <a:avLst/>
+          </a:prstGeom>
+          <a:noFill/>
+        </p:spPr>
+        <p:txBody>
+          <a:bodyPr wrap="none">
+            <a:spAutoFit/>
+          </a:bodyPr>
+          <a:lstStyle/>
+          <a:p>
+            <a:pPr algn="l">
+              <a:defRPr sz="1400" b="1">
+                <a:solidFill>
+                  <a:srgbClr val="FFFFFF"/>
+                </a:solidFill>
+                <a:latin typeface="Arial"/>
+              </a:defRPr>
+            </a:pPr>
+            <a:r>
+              <a:t>Spanisch Klasse 7 · LP-01d</a:t>
+            </a:r>
+          </a:p>
+        </p:txBody>
+      </p:sp>
+      <p:sp>
+        <p:nvSpPr>
+          <p:cNvPr id="4" name="Rectangle 3"/>
+          <p:cNvSpPr/>
+          <p:nvPr/>
+        </p:nvSpPr>
+        <p:spPr>
+          <a:xfrm>
+            <a:off x="0" y="6583680"/>
+            <a:ext cx="12191695" cy="274320"/>
+          </a:xfrm>
+          <a:prstGeom prst="rect">
+            <a:avLst/>
+          </a:prstGeom>
+          <a:solidFill>
+            <a:srgbClr val="F5F5F5"/>
+          </a:solidFill>
+          <a:ln>
+            <a:noFill/>
+          </a:ln>
+        </p:spPr>
+        <p:style>
+          <a:lnRef idx="1">
+            <a:schemeClr val="accent1"/>
+          </a:lnRef>
+          <a:fillRef idx="3">
+            <a:schemeClr val="accent1"/>
+          </a:fillRef>
+          <a:effectRef idx="2">
+            <a:schemeClr val="accent1"/>
+          </a:effectRef>
+          <a:fontRef idx="minor">
+            <a:schemeClr val="lt1"/>
+          </a:fontRef>
+        </p:style>
+        <p:txBody>
+          <a:bodyPr rtlCol="0" anchor="ctr"/>
+          <a:lstStyle/>
+          <a:p>
+            <a:pPr algn="ctr"/>
+          </a:p>
+        </p:txBody>
+      </p:sp>
+      <p:sp>
+        <p:nvSpPr>
+          <p:cNvPr id="5" name="TextBox 4"/>
+          <p:cNvSpPr txBox="1"/>
+          <p:nvPr/>
+        </p:nvSpPr>
+        <p:spPr>
+          <a:xfrm>
+            <a:off x="274320" y="6601968"/>
+            <a:ext cx="4572000" cy="228600"/>
+          </a:xfrm>
+          <a:prstGeom prst="rect">
+            <a:avLst/>
+          </a:prstGeom>
+          <a:noFill/>
+        </p:spPr>
+        <p:txBody>
+          <a:bodyPr wrap="none">
+            <a:spAutoFit/>
+          </a:bodyPr>
+          <a:lstStyle/>
+          <a:p>
+            <a:pPr algn="l">
+              <a:defRPr sz="1000" b="0">
+                <a:solidFill>
+                  <a:srgbClr val="555555"/>
+                </a:solidFill>
+                <a:latin typeface="Arial"/>
+              </a:defRPr>
+            </a:pPr>
+            <a:r>
+              <a:t>¿Qué tal?</a:t>
+            </a:r>
+          </a:p>
+        </p:txBody>
+      </p:sp>
+      <p:sp>
+        <p:nvSpPr>
+          <p:cNvPr id="6" name="TextBox 5"/>
+          <p:cNvSpPr txBox="1"/>
+          <p:nvPr/>
+        </p:nvSpPr>
+        <p:spPr>
+          <a:xfrm>
+            <a:off x="9144000" y="6601968"/>
+            <a:ext cx="2743200" cy="228600"/>
+          </a:xfrm>
+          <a:prstGeom prst="rect">
+            <a:avLst/>
+          </a:prstGeom>
+          <a:noFill/>
+        </p:spPr>
+        <p:txBody>
+          <a:bodyPr wrap="none">
+            <a:spAutoFit/>
+          </a:bodyPr>
+          <a:lstStyle/>
+          <a:p>
+            <a:pPr algn="r">
+              <a:defRPr sz="1000" b="0">
+                <a:solidFill>
+                  <a:srgbClr val="555555"/>
+                </a:solidFill>
+                <a:latin typeface="Arial"/>
+              </a:defRPr>
+            </a:pPr>
+            <a:r>
+              <a:t>Sequenz 1</a:t>
+            </a:r>
+          </a:p>
+        </p:txBody>
+      </p:sp>
+      <p:sp>
+        <p:nvSpPr>
+          <p:cNvPr id="7" name="Rectangle 6"/>
+          <p:cNvSpPr/>
+          <p:nvPr/>
+        </p:nvSpPr>
+        <p:spPr>
+          <a:xfrm>
+            <a:off x="457200" y="640080"/>
+            <a:ext cx="1828800" cy="457200"/>
+          </a:xfrm>
+          <a:prstGeom prst="rect">
+            <a:avLst/>
+          </a:prstGeom>
+          <a:solidFill>
+            <a:srgbClr val="C41E3A"/>
+          </a:solidFill>
+          <a:ln>
+            <a:noFill/>
+          </a:ln>
+        </p:spPr>
+        <p:style>
+          <a:lnRef idx="1">
+            <a:schemeClr val="accent1"/>
+          </a:lnRef>
+          <a:fillRef idx="3">
+            <a:schemeClr val="accent1"/>
+          </a:fillRef>
+          <a:effectRef idx="2">
+            <a:schemeClr val="accent1"/>
+          </a:effectRef>
+          <a:fontRef idx="minor">
+            <a:schemeClr val="lt1"/>
+          </a:fontRef>
+        </p:style>
+        <p:txBody>
+          <a:bodyPr rtlCol="0" anchor="ctr"/>
+          <a:lstStyle/>
+          <a:p>
+            <a:pPr algn="ctr"/>
+          </a:p>
+        </p:txBody>
+      </p:sp>
+      <p:sp>
+        <p:nvSpPr>
+          <p:cNvPr id="8" name="TextBox 7"/>
+          <p:cNvSpPr txBox="1"/>
+          <p:nvPr/>
+        </p:nvSpPr>
+        <p:spPr>
+          <a:xfrm>
+            <a:off x="548640" y="713231"/>
+            <a:ext cx="1645920" cy="320040"/>
+          </a:xfrm>
+          <a:prstGeom prst="rect">
+            <a:avLst/>
+          </a:prstGeom>
+          <a:noFill/>
+        </p:spPr>
+        <p:txBody>
+          <a:bodyPr wrap="none">
+            <a:spAutoFit/>
+          </a:bodyPr>
+          <a:lstStyle/>
+          <a:p>
+            <a:pPr algn="ctr">
+              <a:defRPr sz="1400" b="1">
+                <a:solidFill>
+                  <a:srgbClr val="FFFFFF"/>
+                </a:solidFill>
+                <a:latin typeface="Arial"/>
+              </a:defRPr>
+            </a:pPr>
+            <a:r>
+              <a:t>ÜBUNG</a:t>
+            </a:r>
+          </a:p>
+        </p:txBody>
+      </p:sp>
+      <p:sp>
+        <p:nvSpPr>
+          <p:cNvPr id="9" name="TextBox 8"/>
+          <p:cNvSpPr txBox="1"/>
+          <p:nvPr/>
+        </p:nvSpPr>
+        <p:spPr>
+          <a:xfrm>
+            <a:off x="457200" y="1280160"/>
+            <a:ext cx="11274552" cy="731520"/>
+          </a:xfrm>
+          <a:prstGeom prst="rect">
+            <a:avLst/>
+          </a:prstGeom>
+          <a:noFill/>
+        </p:spPr>
+        <p:txBody>
+          <a:bodyPr wrap="none">
+            <a:spAutoFit/>
+          </a:bodyPr>
+          <a:lstStyle/>
+          <a:p>
+            <a:pPr algn="l">
+              <a:defRPr sz="3200" b="1">
+                <a:solidFill>
+                  <a:srgbClr val="C41E3A"/>
+                </a:solidFill>
+                <a:latin typeface="Arial"/>
+              </a:defRPr>
+            </a:pPr>
+            <a:r>
+              <a:t>✏️ Probe: Artikel</a:t>
+            </a:r>
+          </a:p>
+        </p:txBody>
+      </p:sp>
+      <p:sp>
+        <p:nvSpPr>
+          <p:cNvPr id="10" name="TextBox 9"/>
+          <p:cNvSpPr txBox="1"/>
+          <p:nvPr/>
+        </p:nvSpPr>
+        <p:spPr>
+          <a:xfrm>
+            <a:off x="640080" y="2011680"/>
+            <a:ext cx="5029200" cy="548640"/>
+          </a:xfrm>
+          <a:prstGeom prst="rect">
+            <a:avLst/>
+          </a:prstGeom>
+          <a:noFill/>
+        </p:spPr>
+        <p:txBody>
+          <a:bodyPr wrap="none">
+            <a:spAutoFit/>
+          </a:bodyPr>
+          <a:lstStyle/>
+          <a:p>
+            <a:pPr algn="l">
+              <a:defRPr sz="2200" b="1">
+                <a:solidFill>
+                  <a:srgbClr val="C41E3A"/>
+                </a:solidFill>
+                <a:latin typeface="Arial"/>
+              </a:defRPr>
+            </a:pPr>
+            <a:r>
+              <a:t>___ libro (m.)</a:t>
+            </a:r>
+          </a:p>
+        </p:txBody>
+      </p:sp>
+      <p:sp>
+        <p:nvSpPr>
+          <p:cNvPr id="11" name="TextBox 10"/>
+          <p:cNvSpPr txBox="1"/>
+          <p:nvPr/>
+        </p:nvSpPr>
+        <p:spPr>
+          <a:xfrm>
+            <a:off x="5943600" y="2011680"/>
+            <a:ext cx="5029200" cy="548640"/>
+          </a:xfrm>
+          <a:prstGeom prst="rect">
+            <a:avLst/>
+          </a:prstGeom>
+          <a:noFill/>
+        </p:spPr>
+        <p:txBody>
+          <a:bodyPr wrap="none">
+            <a:spAutoFit/>
+          </a:bodyPr>
+          <a:lstStyle/>
+          <a:p>
+            <a:pPr algn="l">
+              <a:defRPr sz="2200" b="0">
+                <a:solidFill>
+                  <a:srgbClr val="888888"/>
+                </a:solidFill>
+                <a:latin typeface="Arial"/>
+              </a:defRPr>
+            </a:pPr>
+            <a:r>
+              <a:t>___</a:t>
+            </a:r>
+          </a:p>
+        </p:txBody>
+      </p:sp>
+      <p:sp>
+        <p:nvSpPr>
+          <p:cNvPr id="12" name="TextBox 11"/>
+          <p:cNvSpPr txBox="1"/>
+          <p:nvPr/>
+        </p:nvSpPr>
+        <p:spPr>
+          <a:xfrm>
+            <a:off x="640080" y="2926080"/>
+            <a:ext cx="5029200" cy="548640"/>
+          </a:xfrm>
+          <a:prstGeom prst="rect">
+            <a:avLst/>
+          </a:prstGeom>
+          <a:noFill/>
+        </p:spPr>
+        <p:txBody>
+          <a:bodyPr wrap="none">
+            <a:spAutoFit/>
+          </a:bodyPr>
+          <a:lstStyle/>
+          <a:p>
+            <a:pPr algn="l">
+              <a:defRPr sz="2200" b="1">
+                <a:solidFill>
+                  <a:srgbClr val="C41E3A"/>
+                </a:solidFill>
+                <a:latin typeface="Arial"/>
+              </a:defRPr>
+            </a:pPr>
+            <a:r>
+              <a:t>___ profesora (f.)</a:t>
+            </a:r>
+          </a:p>
+        </p:txBody>
+      </p:sp>
+      <p:sp>
+        <p:nvSpPr>
+          <p:cNvPr id="13" name="TextBox 12"/>
+          <p:cNvSpPr txBox="1"/>
+          <p:nvPr/>
+        </p:nvSpPr>
+        <p:spPr>
+          <a:xfrm>
+            <a:off x="5943600" y="2926080"/>
+            <a:ext cx="5029200" cy="548640"/>
+          </a:xfrm>
+          <a:prstGeom prst="rect">
+            <a:avLst/>
+          </a:prstGeom>
+          <a:noFill/>
+        </p:spPr>
+        <p:txBody>
+          <a:bodyPr wrap="none">
+            <a:spAutoFit/>
+          </a:bodyPr>
+          <a:lstStyle/>
+          <a:p>
+            <a:pPr algn="l">
+              <a:defRPr sz="2200" b="0">
+                <a:solidFill>
+                  <a:srgbClr val="888888"/>
+                </a:solidFill>
+                <a:latin typeface="Arial"/>
+              </a:defRPr>
+            </a:pPr>
+            <a:r>
+              <a:t>___</a:t>
+            </a:r>
+          </a:p>
+        </p:txBody>
+      </p:sp>
+      <p:sp>
+        <p:nvSpPr>
+          <p:cNvPr id="14" name="Rectangle 13"/>
+          <p:cNvSpPr/>
+          <p:nvPr/>
+        </p:nvSpPr>
+        <p:spPr>
+          <a:xfrm>
+            <a:off x="457200" y="5943600"/>
+            <a:ext cx="11274552" cy="548640"/>
+          </a:xfrm>
+          <a:prstGeom prst="rect">
+            <a:avLst/>
+          </a:prstGeom>
+          <a:solidFill>
+            <a:srgbClr val="FDF2F4"/>
+          </a:solidFill>
+          <a:ln>
+            <a:solidFill>
+              <a:srgbClr val="C41E3A"/>
+            </a:solidFill>
+          </a:ln>
+        </p:spPr>
+        <p:style>
+          <a:lnRef idx="1">
+            <a:schemeClr val="accent1"/>
+          </a:lnRef>
+          <a:fillRef idx="3">
+            <a:schemeClr val="accent1"/>
+          </a:fillRef>
+          <a:effectRef idx="2">
+            <a:schemeClr val="accent1"/>
+          </a:effectRef>
+          <a:fontRef idx="minor">
+            <a:schemeClr val="lt1"/>
+          </a:fontRef>
+        </p:style>
+        <p:txBody>
+          <a:bodyPr rtlCol="0" anchor="ctr"/>
+          <a:lstStyle/>
+          <a:p>
+            <a:pPr algn="ctr"/>
+          </a:p>
+        </p:txBody>
+      </p:sp>
+      <p:sp>
+        <p:nvSpPr>
+          <p:cNvPr id="15" name="TextBox 14"/>
+          <p:cNvSpPr txBox="1"/>
+          <p:nvPr/>
+        </p:nvSpPr>
+        <p:spPr>
+          <a:xfrm>
+            <a:off x="640080" y="6053328"/>
+            <a:ext cx="10972800" cy="365760"/>
+          </a:xfrm>
+          <a:prstGeom prst="rect">
+            <a:avLst/>
+          </a:prstGeom>
+          <a:noFill/>
+        </p:spPr>
+        <p:txBody>
+          <a:bodyPr wrap="none">
+            <a:spAutoFit/>
+          </a:bodyPr>
+          <a:lstStyle/>
+          <a:p>
+            <a:pPr algn="l">
+              <a:defRPr sz="1400" b="1">
+                <a:solidFill>
+                  <a:srgbClr val="C41E3A"/>
+                </a:solidFill>
+                <a:latin typeface="Arial"/>
+              </a:defRPr>
+            </a:pPr>
+            <a:r>
+              <a:t>📝 MT-01d</a:t>
             </a:r>
           </a:p>
         </p:txBody>

</xml_diff>